<commit_message>
Update pitch deck to include pregnancy during cancer treatment and child's school struggles
Updates presentation slides and script to reflect new narrative elements of Keisha's story, including a concurrent pregnancy and cancer diagnosis, and her child's academic difficulties, illustrating the interconnectedness of the ThriveUp ecosystem across healthcare, education, and social services.

Replit-Commit-Author: Agent
Replit-Commit-Session-Id: 075aae1d-96f4-48c3-9432-c442ac3f20f6
Replit-Commit-Checkpoint-Type: full_checkpoint
Replit-Commit-Event-Id: b6a443bc-88f5-4c95-b829-f1fffe821e85
Replit-Commit-Screenshot-Url: https://storage.googleapis.com/screenshot-production-us-central1/55376bb2-2aea-463e-b6a9-2c1d5c123d53/075aae1d-96f4-48c3-9432-c442ac3f20f6/hVCNBVg
Replit-Helium-Checkpoint-Created: true
</commit_message>
<xml_diff>
--- a/docs/pitches/ThriveUp-The-Pitch-by-Deel-2026.pptx
+++ b/docs/pitches/ThriveUp-The-Pitch-by-Deel-2026.pptx
@@ -3194,12 +3194,12 @@
         </p:nvSpPr>
         <p:spPr>
           <a:xfrm>
-            <a:off x="731520" y="5212080"/>
-            <a:ext cx="10698480" cy="1645920"/>
+            <a:off x="731520" y="5166360"/>
+            <a:ext cx="10698480" cy="1691640"/>
           </a:xfrm>
           <a:prstGeom prst="roundRect">
             <a:avLst>
-              <a:gd name="adj" fmla="val 6667"/>
+              <a:gd name="adj" fmla="val 6486"/>
             </a:avLst>
           </a:prstGeom>
           <a:solidFill>
@@ -3221,8 +3221,8 @@
         </p:nvSpPr>
         <p:spPr>
           <a:xfrm>
-            <a:off x="1005840" y="5257800"/>
-            <a:ext cx="10149840" cy="1005840"/>
+            <a:off x="1005840" y="5212080"/>
+            <a:ext cx="10149840" cy="1234440"/>
           </a:xfrm>
           <a:prstGeom prst="rect">
             <a:avLst/>
@@ -3236,12 +3236,12 @@
           <a:p>
             <a:pPr algn="ctr" indent="0" marL="0">
               <a:lnSpc>
-                <a:spcPct val="135000"/>
+                <a:spcPct val="125000"/>
               </a:lnSpc>
               <a:buNone/>
             </a:pPr>
             <a:r>
-              <a:rPr lang="en-US" sz="1200" i="1" dirty="0">
+              <a:rPr lang="en-US" sz="1100" i="1" dirty="0">
                 <a:solidFill>
                   <a:srgbClr val="8B949E"/>
                 </a:solidFill>
@@ -3251,46 +3251,46 @@
               </a:rPr>
               <a:t>Keisha is not hypothetical. She is every woman in every underserved community in America.</a:t>
             </a:r>
-            <a:endParaRPr lang="en-US" sz="1200" dirty="0"/>
+            <a:endParaRPr lang="en-US" sz="1100" dirty="0"/>
           </a:p>
           <a:p>
             <a:pPr algn="ctr" indent="0" marL="0">
               <a:lnSpc>
-                <a:spcPct val="135000"/>
+                <a:spcPct val="125000"/>
               </a:lnSpc>
               <a:buNone/>
             </a:pPr>
-            <a:r>
-              <a:rPr lang="en-US" sz="1200" i="1" dirty="0">
-                <a:solidFill>
-                  <a:srgbClr val="8B949E"/>
-                </a:solidFill>
-                <a:latin typeface="Arial" pitchFamily="34" charset="0"/>
-                <a:ea typeface="Arial" pitchFamily="34" charset="-122"/>
-                <a:cs typeface="Arial" pitchFamily="34" charset="-120"/>
-              </a:rPr>
-              <a:t>She is a veteran and a mother and a cancer patient and a business owner and a person with depression — all at the same time. The current system treats each of those as a separate problem handled by a separate agency.</a:t>
-            </a:r>
-            <a:endParaRPr lang="en-US" sz="1200" dirty="0"/>
+            <a:endParaRPr lang="en-US" sz="1100" dirty="0"/>
           </a:p>
           <a:p>
             <a:pPr algn="ctr" indent="0" marL="0">
               <a:lnSpc>
-                <a:spcPct val="135000"/>
+                <a:spcPct val="125000"/>
               </a:lnSpc>
               <a:buNone/>
             </a:pPr>
-            <a:endParaRPr lang="en-US" sz="1200" dirty="0"/>
+            <a:r>
+              <a:rPr lang="en-US" sz="1100" i="1" dirty="0">
+                <a:solidFill>
+                  <a:srgbClr val="8B949E"/>
+                </a:solidFill>
+                <a:latin typeface="Arial" pitchFamily="34" charset="0"/>
+                <a:ea typeface="Arial" pitchFamily="34" charset="-122"/>
+                <a:cs typeface="Arial" pitchFamily="34" charset="-120"/>
+              </a:rPr>
+              <a:t>She is a veteran and a mother and a cancer patient and pregnant and depressed — and her child</a:t>
+            </a:r>
+            <a:endParaRPr lang="en-US" sz="1100" dirty="0"/>
           </a:p>
           <a:p>
             <a:pPr algn="ctr" indent="0" marL="0">
               <a:lnSpc>
-                <a:spcPct val="135000"/>
+                <a:spcPct val="125000"/>
               </a:lnSpc>
               <a:buNone/>
             </a:pPr>
             <a:r>
-              <a:rPr lang="en-US" sz="1200" i="1" dirty="0">
+              <a:rPr lang="en-US" sz="1100" i="1" dirty="0">
                 <a:solidFill>
                   <a:srgbClr val="8B949E"/>
                 </a:solidFill>
@@ -3298,9 +3298,58 @@
                 <a:ea typeface="Arial" pitchFamily="34" charset="-122"/>
                 <a:cs typeface="Arial" pitchFamily="34" charset="-120"/>
               </a:rPr>
-              <a:t>ThriveUp treats her as one person. Because she is.</a:t>
-            </a:r>
-            <a:endParaRPr lang="en-US" sz="1200" dirty="0"/>
+              <a:t>is failing in school because of all of it. The school sees a struggling student. The hospital sees a patient.</a:t>
+            </a:r>
+            <a:endParaRPr lang="en-US" sz="1100" dirty="0"/>
+          </a:p>
+          <a:p>
+            <a:pPr algn="ctr" indent="0" marL="0">
+              <a:lnSpc>
+                <a:spcPct val="125000"/>
+              </a:lnSpc>
+              <a:buNone/>
+            </a:pPr>
+            <a:r>
+              <a:rPr lang="en-US" sz="1100" i="1" dirty="0">
+                <a:solidFill>
+                  <a:srgbClr val="8B949E"/>
+                </a:solidFill>
+                <a:latin typeface="Arial" pitchFamily="34" charset="0"/>
+                <a:ea typeface="Arial" pitchFamily="34" charset="-122"/>
+                <a:cs typeface="Arial" pitchFamily="34" charset="-120"/>
+              </a:rPr>
+              <a:t>The workforce board sees an employee. Nobody sees the family.</a:t>
+            </a:r>
+            <a:endParaRPr lang="en-US" sz="1100" dirty="0"/>
+          </a:p>
+          <a:p>
+            <a:pPr algn="ctr" indent="0" marL="0">
+              <a:lnSpc>
+                <a:spcPct val="125000"/>
+              </a:lnSpc>
+              <a:buNone/>
+            </a:pPr>
+            <a:endParaRPr lang="en-US" sz="1100" dirty="0"/>
+          </a:p>
+          <a:p>
+            <a:pPr algn="ctr" indent="0" marL="0">
+              <a:lnSpc>
+                <a:spcPct val="125000"/>
+              </a:lnSpc>
+              <a:buNone/>
+            </a:pPr>
+            <a:r>
+              <a:rPr lang="en-US" sz="1100" i="1" dirty="0">
+                <a:solidFill>
+                  <a:srgbClr val="8B949E"/>
+                </a:solidFill>
+                <a:latin typeface="Arial" pitchFamily="34" charset="0"/>
+                <a:ea typeface="Arial" pitchFamily="34" charset="-122"/>
+                <a:cs typeface="Arial" pitchFamily="34" charset="-120"/>
+              </a:rPr>
+              <a:t>ThriveUp sees the family. Because it's one ecosystem, not eight agencies.</a:t>
+            </a:r>
+            <a:endParaRPr lang="en-US" sz="1100" dirty="0"/>
           </a:p>
         </p:txBody>
       </p:sp>
@@ -3312,8 +3361,8 @@
         </p:nvSpPr>
         <p:spPr>
           <a:xfrm>
-            <a:off x="1005840" y="6263640"/>
-            <a:ext cx="10149840" cy="365760"/>
+            <a:off x="1005840" y="6492240"/>
+            <a:ext cx="10149840" cy="320040"/>
           </a:xfrm>
           <a:prstGeom prst="rect">
             <a:avLst/>
@@ -6260,7 +6309,7 @@
               <a:buNone/>
             </a:pPr>
             <a:r>
-              <a:rPr lang="en-US" sz="1600" i="1" dirty="0">
+              <a:rPr lang="en-US" sz="1500" i="1" dirty="0">
                 <a:solidFill>
                   <a:srgbClr val="00C9A7"/>
                 </a:solidFill>
@@ -6268,9 +6317,9 @@
                 <a:ea typeface="Arial" pitchFamily="34" charset="-122"/>
                 <a:cs typeface="Arial" pitchFamily="34" charset="-120"/>
               </a:rPr>
-              <a:t>She's a veteran. A mother. A breast cancer survivor. She has depression.</a:t>
-            </a:r>
-            <a:endParaRPr lang="en-US" sz="1600" dirty="0"/>
+              <a:t>She's a veteran. A mother. She's battling breast cancer — and just found out she's pregnant.</a:t>
+            </a:r>
+            <a:endParaRPr lang="en-US" sz="1500" dirty="0"/>
           </a:p>
           <a:p>
             <a:pPr indent="0" marL="0">
@@ -6280,7 +6329,7 @@
               <a:buNone/>
             </a:pPr>
             <a:r>
-              <a:rPr lang="en-US" sz="1600" i="1" dirty="0">
+              <a:rPr lang="en-US" sz="1500" i="1" dirty="0">
                 <a:solidFill>
                   <a:srgbClr val="00C9A7"/>
                 </a:solidFill>
@@ -6288,9 +6337,9 @@
                 <a:ea typeface="Arial" pitchFamily="34" charset="-122"/>
                 <a:cs typeface="Arial" pitchFamily="34" charset="-120"/>
               </a:rPr>
-              <a:t>She runs a small nonprofit. She needs community resources. She is every woman.</a:t>
-            </a:r>
-            <a:endParaRPr lang="en-US" sz="1600" dirty="0"/>
+              <a:t>She has depression. She runs a small nonprofit. Her child is failing in school. She is every woman.</a:t>
+            </a:r>
+            <a:endParaRPr lang="en-US" sz="1500" dirty="0"/>
           </a:p>
         </p:txBody>
       </p:sp>
@@ -6302,8 +6351,8 @@
         </p:nvSpPr>
         <p:spPr>
           <a:xfrm>
-            <a:off x="731520" y="2148840"/>
-            <a:ext cx="10515600" cy="777240"/>
+            <a:off x="731520" y="2103120"/>
+            <a:ext cx="10515600" cy="640080"/>
           </a:xfrm>
           <a:prstGeom prst="rect">
             <a:avLst/>
@@ -6317,12 +6366,12 @@
           <a:p>
             <a:pPr indent="0" marL="0">
               <a:lnSpc>
-                <a:spcPct val="140000"/>
+                <a:spcPct val="135000"/>
               </a:lnSpc>
               <a:buNone/>
             </a:pPr>
             <a:r>
-              <a:rPr lang="en-US" sz="1250" dirty="0">
+              <a:rPr lang="en-US" sz="1200" dirty="0">
                 <a:solidFill>
                   <a:srgbClr val="8B949E"/>
                 </a:solidFill>
@@ -6330,38 +6379,9 @@
                 <a:ea typeface="Arial" pitchFamily="34" charset="-122"/>
                 <a:cs typeface="Arial" pitchFamily="34" charset="-120"/>
               </a:rPr>
-              <a:t>In the current system, Keisha would need to navigate 8 disconnected agencies, tell her story 8 times, and hope that someone, somewhere, connects the dots. Nobody does. She falls through the cracks.</a:t>
-            </a:r>
-            <a:endParaRPr lang="en-US" sz="1250" dirty="0"/>
-          </a:p>
-          <a:p>
-            <a:pPr indent="0" marL="0">
-              <a:lnSpc>
-                <a:spcPct val="140000"/>
-              </a:lnSpc>
-              <a:buNone/>
-            </a:pPr>
-            <a:endParaRPr lang="en-US" sz="1250" dirty="0"/>
-          </a:p>
-          <a:p>
-            <a:pPr indent="0" marL="0">
-              <a:lnSpc>
-                <a:spcPct val="140000"/>
-              </a:lnSpc>
-              <a:buNone/>
-            </a:pPr>
-            <a:r>
-              <a:rPr lang="en-US" sz="1250" dirty="0">
-                <a:solidFill>
-                  <a:srgbClr val="8B949E"/>
-                </a:solidFill>
-                <a:latin typeface="Arial" pitchFamily="34" charset="0"/>
-                <a:ea typeface="Arial" pitchFamily="34" charset="-122"/>
-                <a:cs typeface="Arial" pitchFamily="34" charset="-120"/>
-              </a:rPr>
-              <a:t>In the ThriveUp ecosystem, Keisha enters through ANY door — and every platform that can help her already knows she's there:</a:t>
-            </a:r>
-            <a:endParaRPr lang="en-US" sz="1250" dirty="0"/>
+              <a:t>In the current system, Keisha navigates 8+ disconnected agencies and tells her story 8 times. Her oncologist doesn't know she's pregnant. Her OB doesn't know she has cancer. Her child's school doesn't know why grades are dropping. In ThriveUp — she walks through any door and every platform responds:</a:t>
+            </a:r>
+            <a:endParaRPr lang="en-US" sz="1200" dirty="0"/>
           </a:p>
         </p:txBody>
       </p:sp>
@@ -6373,12 +6393,12 @@
         </p:nvSpPr>
         <p:spPr>
           <a:xfrm>
-            <a:off x="274320" y="3108960"/>
-            <a:ext cx="3703320" cy="1691640"/>
+            <a:off x="274320" y="2926080"/>
+            <a:ext cx="3703320" cy="1783080"/>
           </a:xfrm>
           <a:prstGeom prst="roundRect">
             <a:avLst>
-              <a:gd name="adj" fmla="val 4324"/>
+              <a:gd name="adj" fmla="val 4103"/>
             </a:avLst>
           </a:prstGeom>
           <a:solidFill>
@@ -6400,24 +6420,24 @@
         </p:nvSpPr>
         <p:spPr>
           <a:xfrm>
-            <a:off x="365760" y="3136392"/>
-            <a:ext cx="1737360" cy="320040"/>
-          </a:xfrm>
-          <a:prstGeom prst="rect">
-            <a:avLst/>
-          </a:prstGeom>
-          <a:noFill/>
-          <a:ln/>
-        </p:spPr>
-        <p:txBody>
-          <a:bodyPr wrap="square" rtlCol="0" anchor="ctr"/>
-          <a:lstStyle/>
-          <a:p>
-            <a:pPr indent="0" marL="0">
-              <a:buNone/>
-            </a:pPr>
-            <a:r>
-              <a:rPr lang="en-US" sz="1100" b="1" dirty="0">
+            <a:off x="365760" y="2953512"/>
+            <a:ext cx="2011680" cy="320040"/>
+          </a:xfrm>
+          <a:prstGeom prst="rect">
+            <a:avLst/>
+          </a:prstGeom>
+          <a:noFill/>
+          <a:ln/>
+        </p:spPr>
+        <p:txBody>
+          <a:bodyPr wrap="square" rtlCol="0" anchor="ctr"/>
+          <a:lstStyle/>
+          <a:p>
+            <a:pPr indent="0" marL="0">
+              <a:buNone/>
+            </a:pPr>
+            <a:r>
+              <a:rPr lang="en-US" sz="1200" b="1" dirty="0">
                 <a:solidFill>
                   <a:srgbClr val="2EA043"/>
                 </a:solidFill>
@@ -6427,7 +6447,7 @@
               </a:rPr>
               <a:t>She's a veteran.</a:t>
             </a:r>
-            <a:endParaRPr lang="en-US" sz="1100" dirty="0"/>
+            <a:endParaRPr lang="en-US" sz="1200" dirty="0"/>
           </a:p>
         </p:txBody>
       </p:sp>
@@ -6439,8 +6459,8 @@
         </p:nvSpPr>
         <p:spPr>
           <a:xfrm>
-            <a:off x="2103120" y="3136392"/>
-            <a:ext cx="1783080" cy="320040"/>
+            <a:off x="2286000" y="2953512"/>
+            <a:ext cx="1600200" cy="320040"/>
           </a:xfrm>
           <a:prstGeom prst="rect">
             <a:avLst/>
@@ -6456,7 +6476,7 @@
               <a:buNone/>
             </a:pPr>
             <a:r>
-              <a:rPr lang="en-US" sz="1100" b="1" dirty="0">
+              <a:rPr lang="en-US" sz="1050" b="1" dirty="0">
                 <a:solidFill>
                   <a:srgbClr val="FFFFFF"/>
                 </a:solidFill>
@@ -6466,7 +6486,7 @@
               </a:rPr>
               <a:t>Mission Transition</a:t>
             </a:r>
-            <a:endParaRPr lang="en-US" sz="1100" dirty="0"/>
+            <a:endParaRPr lang="en-US" sz="1050" dirty="0"/>
           </a:p>
         </p:txBody>
       </p:sp>
@@ -6478,8 +6498,8 @@
         </p:nvSpPr>
         <p:spPr>
           <a:xfrm>
-            <a:off x="457200" y="3474720"/>
-            <a:ext cx="3337560" cy="18288"/>
+            <a:off x="411480" y="3291840"/>
+            <a:ext cx="3429000" cy="18288"/>
           </a:xfrm>
           <a:prstGeom prst="rect">
             <a:avLst/>
@@ -6498,8 +6518,8 @@
         </p:nvSpPr>
         <p:spPr>
           <a:xfrm>
-            <a:off x="365760" y="3566160"/>
-            <a:ext cx="3520440" cy="1097280"/>
+            <a:off x="365760" y="3383280"/>
+            <a:ext cx="3520440" cy="1188720"/>
           </a:xfrm>
           <a:prstGeom prst="rect">
             <a:avLst/>
@@ -6540,12 +6560,179 @@
         </p:nvSpPr>
         <p:spPr>
           <a:xfrm>
-            <a:off x="4160520" y="3108960"/>
-            <a:ext cx="3703320" cy="1691640"/>
+            <a:off x="4160520" y="2926080"/>
+            <a:ext cx="3703320" cy="1783080"/>
           </a:xfrm>
           <a:prstGeom prst="roundRect">
             <a:avLst>
-              <a:gd name="adj" fmla="val 4324"/>
+              <a:gd name="adj" fmla="val 4103"/>
+            </a:avLst>
+          </a:prstGeom>
+          <a:solidFill>
+            <a:srgbClr val="161B22"/>
+          </a:solidFill>
+          <a:ln w="19050">
+            <a:solidFill>
+              <a:srgbClr val="8B5CF6"/>
+            </a:solidFill>
+            <a:prstDash val="solid"/>
+          </a:ln>
+        </p:spPr>
+      </p:sp>
+      <p:sp>
+        <p:nvSpPr>
+          <p:cNvPr id="12" name="Text 10"/>
+          <p:cNvSpPr/>
+          <p:nvPr/>
+        </p:nvSpPr>
+        <p:spPr>
+          <a:xfrm>
+            <a:off x="4251960" y="2953512"/>
+            <a:ext cx="2011680" cy="320040"/>
+          </a:xfrm>
+          <a:prstGeom prst="rect">
+            <a:avLst/>
+          </a:prstGeom>
+          <a:noFill/>
+          <a:ln/>
+        </p:spPr>
+        <p:txBody>
+          <a:bodyPr wrap="square" rtlCol="0" anchor="ctr"/>
+          <a:lstStyle/>
+          <a:p>
+            <a:pPr indent="0" marL="0">
+              <a:buNone/>
+            </a:pPr>
+            <a:r>
+              <a:rPr lang="en-US" sz="1200" b="1" dirty="0">
+                <a:solidFill>
+                  <a:srgbClr val="8B5CF6"/>
+                </a:solidFill>
+                <a:latin typeface="Arial" pitchFamily="34" charset="0"/>
+                <a:ea typeface="Arial" pitchFamily="34" charset="-122"/>
+                <a:cs typeface="Arial" pitchFamily="34" charset="-120"/>
+              </a:rPr>
+              <a:t>She has breast cancer.</a:t>
+            </a:r>
+            <a:endParaRPr lang="en-US" sz="1200" dirty="0"/>
+          </a:p>
+        </p:txBody>
+      </p:sp>
+      <p:sp>
+        <p:nvSpPr>
+          <p:cNvPr id="13" name="Text 11"/>
+          <p:cNvSpPr/>
+          <p:nvPr/>
+        </p:nvSpPr>
+        <p:spPr>
+          <a:xfrm>
+            <a:off x="6172200" y="2953512"/>
+            <a:ext cx="1600200" cy="320040"/>
+          </a:xfrm>
+          <a:prstGeom prst="rect">
+            <a:avLst/>
+          </a:prstGeom>
+          <a:noFill/>
+          <a:ln/>
+        </p:spPr>
+        <p:txBody>
+          <a:bodyPr wrap="square" rtlCol="0" anchor="ctr"/>
+          <a:lstStyle/>
+          <a:p>
+            <a:pPr algn="r" indent="0" marL="0">
+              <a:buNone/>
+            </a:pPr>
+            <a:r>
+              <a:rPr lang="en-US" sz="1050" b="1" dirty="0">
+                <a:solidFill>
+                  <a:srgbClr val="FFFFFF"/>
+                </a:solidFill>
+                <a:latin typeface="Arial" pitchFamily="34" charset="0"/>
+                <a:ea typeface="Arial" pitchFamily="34" charset="-122"/>
+                <a:cs typeface="Arial" pitchFamily="34" charset="-120"/>
+              </a:rPr>
+              <a:t>Sankofa Health</a:t>
+            </a:r>
+            <a:endParaRPr lang="en-US" sz="1050" dirty="0"/>
+          </a:p>
+        </p:txBody>
+      </p:sp>
+      <p:sp>
+        <p:nvSpPr>
+          <p:cNvPr id="14" name="Shape 12"/>
+          <p:cNvSpPr/>
+          <p:nvPr/>
+        </p:nvSpPr>
+        <p:spPr>
+          <a:xfrm>
+            <a:off x="4297680" y="3291840"/>
+            <a:ext cx="3429000" cy="18288"/>
+          </a:xfrm>
+          <a:prstGeom prst="rect">
+            <a:avLst/>
+          </a:prstGeom>
+          <a:solidFill>
+            <a:srgbClr val="8B5CF6"/>
+          </a:solidFill>
+          <a:ln/>
+        </p:spPr>
+      </p:sp>
+      <p:sp>
+        <p:nvSpPr>
+          <p:cNvPr id="15" name="Text 13"/>
+          <p:cNvSpPr/>
+          <p:nvPr/>
+        </p:nvSpPr>
+        <p:spPr>
+          <a:xfrm>
+            <a:off x="4251960" y="3383280"/>
+            <a:ext cx="3520440" cy="1188720"/>
+          </a:xfrm>
+          <a:prstGeom prst="rect">
+            <a:avLst/>
+          </a:prstGeom>
+          <a:noFill/>
+          <a:ln/>
+        </p:spPr>
+        <p:txBody>
+          <a:bodyPr wrap="square" rtlCol="0" anchor="ctr"/>
+          <a:lstStyle/>
+          <a:p>
+            <a:pPr indent="0" marL="0">
+              <a:lnSpc>
+                <a:spcPct val="130000"/>
+              </a:lnSpc>
+              <a:buNone/>
+            </a:pPr>
+            <a:r>
+              <a:rPr lang="en-US" sz="1000" dirty="0">
+                <a:solidFill>
+                  <a:srgbClr val="8B949E"/>
+                </a:solidFill>
+                <a:latin typeface="Arial" pitchFamily="34" charset="0"/>
+                <a:ea typeface="Arial" pitchFamily="34" charset="-122"/>
+                <a:cs typeface="Arial" pitchFamily="34" charset="-120"/>
+              </a:rPr>
+              <a:t>Screening navigation, genetic counseling, survivor support. Connected to her OB, her mental health provider, her medication management.</a:t>
+            </a:r>
+            <a:endParaRPr lang="en-US" sz="1000" dirty="0"/>
+          </a:p>
+        </p:txBody>
+      </p:sp>
+      <p:sp>
+        <p:nvSpPr>
+          <p:cNvPr id="16" name="Shape 14"/>
+          <p:cNvSpPr/>
+          <p:nvPr/>
+        </p:nvSpPr>
+        <p:spPr>
+          <a:xfrm>
+            <a:off x="8046720" y="2926080"/>
+            <a:ext cx="3703320" cy="1783080"/>
+          </a:xfrm>
+          <a:prstGeom prst="roundRect">
+            <a:avLst>
+              <a:gd name="adj" fmla="val 4103"/>
             </a:avLst>
           </a:prstGeom>
           <a:solidFill>
@@ -6561,30 +6748,30 @@
       </p:sp>
       <p:sp>
         <p:nvSpPr>
-          <p:cNvPr id="12" name="Text 10"/>
-          <p:cNvSpPr/>
-          <p:nvPr/>
-        </p:nvSpPr>
-        <p:spPr>
-          <a:xfrm>
-            <a:off x="4251960" y="3136392"/>
-            <a:ext cx="1737360" cy="320040"/>
-          </a:xfrm>
-          <a:prstGeom prst="rect">
-            <a:avLst/>
-          </a:prstGeom>
-          <a:noFill/>
-          <a:ln/>
-        </p:spPr>
-        <p:txBody>
-          <a:bodyPr wrap="square" rtlCol="0" anchor="ctr"/>
-          <a:lstStyle/>
-          <a:p>
-            <a:pPr indent="0" marL="0">
-              <a:buNone/>
-            </a:pPr>
-            <a:r>
-              <a:rPr lang="en-US" sz="1100" b="1" dirty="0">
+          <p:cNvPr id="17" name="Text 15"/>
+          <p:cNvSpPr/>
+          <p:nvPr/>
+        </p:nvSpPr>
+        <p:spPr>
+          <a:xfrm>
+            <a:off x="8138160" y="2953512"/>
+            <a:ext cx="2011680" cy="320040"/>
+          </a:xfrm>
+          <a:prstGeom prst="rect">
+            <a:avLst/>
+          </a:prstGeom>
+          <a:noFill/>
+          <a:ln/>
+        </p:spPr>
+        <p:txBody>
+          <a:bodyPr wrap="square" rtlCol="0" anchor="ctr"/>
+          <a:lstStyle/>
+          <a:p>
+            <a:pPr indent="0" marL="0">
+              <a:buNone/>
+            </a:pPr>
+            <a:r>
+              <a:rPr lang="en-US" sz="1200" b="1" dirty="0">
                 <a:solidFill>
                   <a:srgbClr val="E8459E"/>
                 </a:solidFill>
@@ -6592,22 +6779,22 @@
                 <a:ea typeface="Arial" pitchFamily="34" charset="-122"/>
                 <a:cs typeface="Arial" pitchFamily="34" charset="-120"/>
               </a:rPr>
-              <a:t>She's a mother.</a:t>
-            </a:r>
-            <a:endParaRPr lang="en-US" sz="1100" dirty="0"/>
-          </a:p>
-        </p:txBody>
-      </p:sp>
-      <p:sp>
-        <p:nvSpPr>
-          <p:cNvPr id="13" name="Text 11"/>
-          <p:cNvSpPr/>
-          <p:nvPr/>
-        </p:nvSpPr>
-        <p:spPr>
-          <a:xfrm>
-            <a:off x="5989320" y="3136392"/>
-            <a:ext cx="1783080" cy="320040"/>
+              <a:t>She's pregnant.</a:t>
+            </a:r>
+            <a:endParaRPr lang="en-US" sz="1200" dirty="0"/>
+          </a:p>
+        </p:txBody>
+      </p:sp>
+      <p:sp>
+        <p:nvSpPr>
+          <p:cNvPr id="18" name="Text 16"/>
+          <p:cNvSpPr/>
+          <p:nvPr/>
+        </p:nvSpPr>
+        <p:spPr>
+          <a:xfrm>
+            <a:off x="10058400" y="2953512"/>
+            <a:ext cx="1600200" cy="320040"/>
           </a:xfrm>
           <a:prstGeom prst="rect">
             <a:avLst/>
@@ -6623,7 +6810,7 @@
               <a:buNone/>
             </a:pPr>
             <a:r>
-              <a:rPr lang="en-US" sz="1100" b="1" dirty="0">
+              <a:rPr lang="en-US" sz="1050" b="1" dirty="0">
                 <a:solidFill>
                   <a:srgbClr val="FFFFFF"/>
                 </a:solidFill>
@@ -6633,20 +6820,20 @@
               </a:rPr>
               <a:t>Black Maternal Health</a:t>
             </a:r>
-            <a:endParaRPr lang="en-US" sz="1100" dirty="0"/>
-          </a:p>
-        </p:txBody>
-      </p:sp>
-      <p:sp>
-        <p:nvSpPr>
-          <p:cNvPr id="14" name="Shape 12"/>
-          <p:cNvSpPr/>
-          <p:nvPr/>
-        </p:nvSpPr>
-        <p:spPr>
-          <a:xfrm>
-            <a:off x="4343400" y="3474720"/>
-            <a:ext cx="3337560" cy="18288"/>
+            <a:endParaRPr lang="en-US" sz="1050" dirty="0"/>
+          </a:p>
+        </p:txBody>
+      </p:sp>
+      <p:sp>
+        <p:nvSpPr>
+          <p:cNvPr id="19" name="Shape 17"/>
+          <p:cNvSpPr/>
+          <p:nvPr/>
+        </p:nvSpPr>
+        <p:spPr>
+          <a:xfrm>
+            <a:off x="8183880" y="3291840"/>
+            <a:ext cx="3429000" cy="18288"/>
           </a:xfrm>
           <a:prstGeom prst="rect">
             <a:avLst/>
@@ -6659,14 +6846,14 @@
       </p:sp>
       <p:sp>
         <p:nvSpPr>
-          <p:cNvPr id="15" name="Text 13"/>
-          <p:cNvSpPr/>
-          <p:nvPr/>
-        </p:nvSpPr>
-        <p:spPr>
-          <a:xfrm>
-            <a:off x="4251960" y="3566160"/>
-            <a:ext cx="3520440" cy="1097280"/>
+          <p:cNvPr id="20" name="Text 18"/>
+          <p:cNvSpPr/>
+          <p:nvPr/>
+        </p:nvSpPr>
+        <p:spPr>
+          <a:xfrm>
+            <a:off x="8138160" y="3383280"/>
+            <a:ext cx="3520440" cy="1188720"/>
           </a:xfrm>
           <a:prstGeom prst="rect">
             <a:avLst/>
@@ -6693,7 +6880,7 @@
                 <a:ea typeface="Arial" pitchFamily="34" charset="-122"/>
                 <a:cs typeface="Arial" pitchFamily="34" charset="-120"/>
               </a:rPr>
-              <a:t>Prenatal/postnatal care, doula coordination, AI risk screening. If her job is threatened, workforce platform flags it.</a:t>
+              <a:t>High-risk pregnancy protocol. AI flags the cancer overlap. Her oncologist and OB are in the same ecosystem — they SEE each other's treatment plans.</a:t>
             </a:r>
             <a:endParaRPr lang="en-US" sz="1000" dirty="0"/>
           </a:p>
@@ -6701,185 +6888,18 @@
       </p:sp>
       <p:sp>
         <p:nvSpPr>
-          <p:cNvPr id="16" name="Shape 14"/>
-          <p:cNvSpPr/>
-          <p:nvPr/>
-        </p:nvSpPr>
-        <p:spPr>
-          <a:xfrm>
-            <a:off x="8046720" y="3108960"/>
-            <a:ext cx="3703320" cy="1691640"/>
+          <p:cNvPr id="21" name="Shape 19"/>
+          <p:cNvSpPr/>
+          <p:nvPr/>
+        </p:nvSpPr>
+        <p:spPr>
+          <a:xfrm>
+            <a:off x="274320" y="4892040"/>
+            <a:ext cx="3703320" cy="1783080"/>
           </a:xfrm>
           <a:prstGeom prst="roundRect">
             <a:avLst>
-              <a:gd name="adj" fmla="val 4324"/>
-            </a:avLst>
-          </a:prstGeom>
-          <a:solidFill>
-            <a:srgbClr val="161B22"/>
-          </a:solidFill>
-          <a:ln w="19050">
-            <a:solidFill>
-              <a:srgbClr val="8B5CF6"/>
-            </a:solidFill>
-            <a:prstDash val="solid"/>
-          </a:ln>
-        </p:spPr>
-      </p:sp>
-      <p:sp>
-        <p:nvSpPr>
-          <p:cNvPr id="17" name="Text 15"/>
-          <p:cNvSpPr/>
-          <p:nvPr/>
-        </p:nvSpPr>
-        <p:spPr>
-          <a:xfrm>
-            <a:off x="8138160" y="3136392"/>
-            <a:ext cx="1737360" cy="320040"/>
-          </a:xfrm>
-          <a:prstGeom prst="rect">
-            <a:avLst/>
-          </a:prstGeom>
-          <a:noFill/>
-          <a:ln/>
-        </p:spPr>
-        <p:txBody>
-          <a:bodyPr wrap="square" rtlCol="0" anchor="ctr"/>
-          <a:lstStyle/>
-          <a:p>
-            <a:pPr indent="0" marL="0">
-              <a:buNone/>
-            </a:pPr>
-            <a:r>
-              <a:rPr lang="en-US" sz="1100" b="1" dirty="0">
-                <a:solidFill>
-                  <a:srgbClr val="8B5CF6"/>
-                </a:solidFill>
-                <a:latin typeface="Arial" pitchFamily="34" charset="0"/>
-                <a:ea typeface="Arial" pitchFamily="34" charset="-122"/>
-                <a:cs typeface="Arial" pitchFamily="34" charset="-120"/>
-              </a:rPr>
-              <a:t>She has breast cancer.</a:t>
-            </a:r>
-            <a:endParaRPr lang="en-US" sz="1100" dirty="0"/>
-          </a:p>
-        </p:txBody>
-      </p:sp>
-      <p:sp>
-        <p:nvSpPr>
-          <p:cNvPr id="18" name="Text 16"/>
-          <p:cNvSpPr/>
-          <p:nvPr/>
-        </p:nvSpPr>
-        <p:spPr>
-          <a:xfrm>
-            <a:off x="9875520" y="3136392"/>
-            <a:ext cx="1783080" cy="320040"/>
-          </a:xfrm>
-          <a:prstGeom prst="rect">
-            <a:avLst/>
-          </a:prstGeom>
-          <a:noFill/>
-          <a:ln/>
-        </p:spPr>
-        <p:txBody>
-          <a:bodyPr wrap="square" rtlCol="0" anchor="ctr"/>
-          <a:lstStyle/>
-          <a:p>
-            <a:pPr algn="r" indent="0" marL="0">
-              <a:buNone/>
-            </a:pPr>
-            <a:r>
-              <a:rPr lang="en-US" sz="1100" b="1" dirty="0">
-                <a:solidFill>
-                  <a:srgbClr val="FFFFFF"/>
-                </a:solidFill>
-                <a:latin typeface="Arial" pitchFamily="34" charset="0"/>
-                <a:ea typeface="Arial" pitchFamily="34" charset="-122"/>
-                <a:cs typeface="Arial" pitchFamily="34" charset="-120"/>
-              </a:rPr>
-              <a:t>Sankofa Health</a:t>
-            </a:r>
-            <a:endParaRPr lang="en-US" sz="1100" dirty="0"/>
-          </a:p>
-        </p:txBody>
-      </p:sp>
-      <p:sp>
-        <p:nvSpPr>
-          <p:cNvPr id="19" name="Shape 17"/>
-          <p:cNvSpPr/>
-          <p:nvPr/>
-        </p:nvSpPr>
-        <p:spPr>
-          <a:xfrm>
-            <a:off x="8229600" y="3474720"/>
-            <a:ext cx="3337560" cy="18288"/>
-          </a:xfrm>
-          <a:prstGeom prst="rect">
-            <a:avLst/>
-          </a:prstGeom>
-          <a:solidFill>
-            <a:srgbClr val="8B5CF6"/>
-          </a:solidFill>
-          <a:ln/>
-        </p:spPr>
-      </p:sp>
-      <p:sp>
-        <p:nvSpPr>
-          <p:cNvPr id="20" name="Text 18"/>
-          <p:cNvSpPr/>
-          <p:nvPr/>
-        </p:nvSpPr>
-        <p:spPr>
-          <a:xfrm>
-            <a:off x="8138160" y="3566160"/>
-            <a:ext cx="3520440" cy="1097280"/>
-          </a:xfrm>
-          <a:prstGeom prst="rect">
-            <a:avLst/>
-          </a:prstGeom>
-          <a:noFill/>
-          <a:ln/>
-        </p:spPr>
-        <p:txBody>
-          <a:bodyPr wrap="square" rtlCol="0" anchor="ctr"/>
-          <a:lstStyle/>
-          <a:p>
-            <a:pPr indent="0" marL="0">
-              <a:lnSpc>
-                <a:spcPct val="130000"/>
-              </a:lnSpc>
-              <a:buNone/>
-            </a:pPr>
-            <a:r>
-              <a:rPr lang="en-US" sz="1000" dirty="0">
-                <a:solidFill>
-                  <a:srgbClr val="8B949E"/>
-                </a:solidFill>
-                <a:latin typeface="Arial" pitchFamily="34" charset="0"/>
-                <a:ea typeface="Arial" pitchFamily="34" charset="-122"/>
-                <a:cs typeface="Arial" pitchFamily="34" charset="-120"/>
-              </a:rPr>
-              <a:t>Screening navigation, genetic counseling, survivor support. Connected to her behavioral health and medication management.</a:t>
-            </a:r>
-            <a:endParaRPr lang="en-US" sz="1000" dirty="0"/>
-          </a:p>
-        </p:txBody>
-      </p:sp>
-      <p:sp>
-        <p:nvSpPr>
-          <p:cNvPr id="21" name="Shape 19"/>
-          <p:cNvSpPr/>
-          <p:nvPr/>
-        </p:nvSpPr>
-        <p:spPr>
-          <a:xfrm>
-            <a:off x="274320" y="4983480"/>
-            <a:ext cx="3703320" cy="1691640"/>
-          </a:xfrm>
-          <a:prstGeom prst="roundRect">
-            <a:avLst>
-              <a:gd name="adj" fmla="val 4324"/>
+              <a:gd name="adj" fmla="val 4103"/>
             </a:avLst>
           </a:prstGeom>
           <a:solidFill>
@@ -6901,24 +6921,24 @@
         </p:nvSpPr>
         <p:spPr>
           <a:xfrm>
-            <a:off x="365760" y="5010912"/>
-            <a:ext cx="1737360" cy="320040"/>
-          </a:xfrm>
-          <a:prstGeom prst="rect">
-            <a:avLst/>
-          </a:prstGeom>
-          <a:noFill/>
-          <a:ln/>
-        </p:spPr>
-        <p:txBody>
-          <a:bodyPr wrap="square" rtlCol="0" anchor="ctr"/>
-          <a:lstStyle/>
-          <a:p>
-            <a:pPr indent="0" marL="0">
-              <a:buNone/>
-            </a:pPr>
-            <a:r>
-              <a:rPr lang="en-US" sz="1100" b="1" dirty="0">
+            <a:off x="365760" y="4919472"/>
+            <a:ext cx="2011680" cy="320040"/>
+          </a:xfrm>
+          <a:prstGeom prst="rect">
+            <a:avLst/>
+          </a:prstGeom>
+          <a:noFill/>
+          <a:ln/>
+        </p:spPr>
+        <p:txBody>
+          <a:bodyPr wrap="square" rtlCol="0" anchor="ctr"/>
+          <a:lstStyle/>
+          <a:p>
+            <a:pPr indent="0" marL="0">
+              <a:buNone/>
+            </a:pPr>
+            <a:r>
+              <a:rPr lang="en-US" sz="1200" b="1" dirty="0">
                 <a:solidFill>
                   <a:srgbClr val="0079F2"/>
                 </a:solidFill>
@@ -6928,7 +6948,7 @@
               </a:rPr>
               <a:t>She has depression.</a:t>
             </a:r>
-            <a:endParaRPr lang="en-US" sz="1100" dirty="0"/>
+            <a:endParaRPr lang="en-US" sz="1200" dirty="0"/>
           </a:p>
         </p:txBody>
       </p:sp>
@@ -6940,8 +6960,8 @@
         </p:nvSpPr>
         <p:spPr>
           <a:xfrm>
-            <a:off x="2103120" y="5010912"/>
-            <a:ext cx="1783080" cy="320040"/>
+            <a:off x="2286000" y="4919472"/>
+            <a:ext cx="1600200" cy="320040"/>
           </a:xfrm>
           <a:prstGeom prst="rect">
             <a:avLst/>
@@ -6957,7 +6977,7 @@
               <a:buNone/>
             </a:pPr>
             <a:r>
-              <a:rPr lang="en-US" sz="1100" b="1" dirty="0">
+              <a:rPr lang="en-US" sz="1050" b="1" dirty="0">
                 <a:solidFill>
                   <a:srgbClr val="FFFFFF"/>
                 </a:solidFill>
@@ -6967,7 +6987,7 @@
               </a:rPr>
               <a:t>Whole-Person Health</a:t>
             </a:r>
-            <a:endParaRPr lang="en-US" sz="1100" dirty="0"/>
+            <a:endParaRPr lang="en-US" sz="1050" dirty="0"/>
           </a:p>
         </p:txBody>
       </p:sp>
@@ -6979,8 +6999,8 @@
         </p:nvSpPr>
         <p:spPr>
           <a:xfrm>
-            <a:off x="457200" y="5349240"/>
-            <a:ext cx="3337560" cy="18288"/>
+            <a:off x="411480" y="5257800"/>
+            <a:ext cx="3429000" cy="18288"/>
           </a:xfrm>
           <a:prstGeom prst="rect">
             <a:avLst/>
@@ -6999,8 +7019,8 @@
         </p:nvSpPr>
         <p:spPr>
           <a:xfrm>
-            <a:off x="365760" y="5440680"/>
-            <a:ext cx="3520440" cy="1097280"/>
+            <a:off x="365760" y="5349240"/>
+            <a:ext cx="3520440" cy="1188720"/>
           </a:xfrm>
           <a:prstGeom prst="rect">
             <a:avLst/>
@@ -7027,7 +7047,7 @@
                 <a:ea typeface="Arial" pitchFamily="34" charset="-122"/>
                 <a:cs typeface="Arial" pitchFamily="34" charset="-120"/>
               </a:rPr>
-              <a:t>Culturally matched counselor, medication tracking via PillScheduler, cognitive screening via SafeCogniCare.</a:t>
+              <a:t>Culturally matched counselor. PillScheduler coordinates BOTH chemo and prenatal meds. SafeCogniCare monitors cognitive impact.</a:t>
             </a:r>
             <a:endParaRPr lang="en-US" sz="1000" dirty="0"/>
           </a:p>
@@ -7041,12 +7061,12 @@
         </p:nvSpPr>
         <p:spPr>
           <a:xfrm>
-            <a:off x="4160520" y="4983480"/>
-            <a:ext cx="3703320" cy="1691640"/>
+            <a:off x="4160520" y="4892040"/>
+            <a:ext cx="3703320" cy="1783080"/>
           </a:xfrm>
           <a:prstGeom prst="roundRect">
             <a:avLst>
-              <a:gd name="adj" fmla="val 4324"/>
+              <a:gd name="adj" fmla="val 4103"/>
             </a:avLst>
           </a:prstGeom>
           <a:solidFill>
@@ -7068,24 +7088,24 @@
         </p:nvSpPr>
         <p:spPr>
           <a:xfrm>
-            <a:off x="4251960" y="5010912"/>
-            <a:ext cx="1737360" cy="320040"/>
-          </a:xfrm>
-          <a:prstGeom prst="rect">
-            <a:avLst/>
-          </a:prstGeom>
-          <a:noFill/>
-          <a:ln/>
-        </p:spPr>
-        <p:txBody>
-          <a:bodyPr wrap="square" rtlCol="0" anchor="ctr"/>
-          <a:lstStyle/>
-          <a:p>
-            <a:pPr indent="0" marL="0">
-              <a:buNone/>
-            </a:pPr>
-            <a:r>
-              <a:rPr lang="en-US" sz="1100" b="1" dirty="0">
+            <a:off x="4251960" y="4919472"/>
+            <a:ext cx="2011680" cy="320040"/>
+          </a:xfrm>
+          <a:prstGeom prst="rect">
+            <a:avLst/>
+          </a:prstGeom>
+          <a:noFill/>
+          <a:ln/>
+        </p:spPr>
+        <p:txBody>
+          <a:bodyPr wrap="square" rtlCol="0" anchor="ctr"/>
+          <a:lstStyle/>
+          <a:p>
+            <a:pPr indent="0" marL="0">
+              <a:buNone/>
+            </a:pPr>
+            <a:r>
+              <a:rPr lang="en-US" sz="1200" b="1" dirty="0">
                 <a:solidFill>
                   <a:srgbClr val="F0B429"/>
                 </a:solidFill>
@@ -7093,9 +7113,9 @@
                 <a:ea typeface="Arial" pitchFamily="34" charset="-122"/>
                 <a:cs typeface="Arial" pitchFamily="34" charset="-120"/>
               </a:rPr>
-              <a:t>She runs a nonprofit.</a:t>
-            </a:r>
-            <a:endParaRPr lang="en-US" sz="1100" dirty="0"/>
+              <a:t>Her child is struggling.</a:t>
+            </a:r>
+            <a:endParaRPr lang="en-US" sz="1200" dirty="0"/>
           </a:p>
         </p:txBody>
       </p:sp>
@@ -7107,8 +7127,8 @@
         </p:nvSpPr>
         <p:spPr>
           <a:xfrm>
-            <a:off x="5989320" y="5010912"/>
-            <a:ext cx="1783080" cy="320040"/>
+            <a:off x="6172200" y="4919472"/>
+            <a:ext cx="1600200" cy="320040"/>
           </a:xfrm>
           <a:prstGeom prst="rect">
             <a:avLst/>
@@ -7124,7 +7144,7 @@
               <a:buNone/>
             </a:pPr>
             <a:r>
-              <a:rPr lang="en-US" sz="1100" b="1" dirty="0">
+              <a:rPr lang="en-US" sz="1050" b="1" dirty="0">
                 <a:solidFill>
                   <a:srgbClr val="FFFFFF"/>
                 </a:solidFill>
@@ -7132,9 +7152,9 @@
                 <a:ea typeface="Arial" pitchFamily="34" charset="-122"/>
                 <a:cs typeface="Arial" pitchFamily="34" charset="-120"/>
               </a:rPr>
-              <a:t>Minority Center of Excellence</a:t>
-            </a:r>
-            <a:endParaRPr lang="en-US" sz="1100" dirty="0"/>
+              <a:t>ISSS + ThriveUp Academy</a:t>
+            </a:r>
+            <a:endParaRPr lang="en-US" sz="1050" dirty="0"/>
           </a:p>
         </p:txBody>
       </p:sp>
@@ -7146,8 +7166,8 @@
         </p:nvSpPr>
         <p:spPr>
           <a:xfrm>
-            <a:off x="4343400" y="5349240"/>
-            <a:ext cx="3337560" cy="18288"/>
+            <a:off x="4297680" y="5257800"/>
+            <a:ext cx="3429000" cy="18288"/>
           </a:xfrm>
           <a:prstGeom prst="rect">
             <a:avLst/>
@@ -7166,8 +7186,8 @@
         </p:nvSpPr>
         <p:spPr>
           <a:xfrm>
-            <a:off x="4251960" y="5440680"/>
-            <a:ext cx="3520440" cy="1097280"/>
+            <a:off x="4251960" y="5349240"/>
+            <a:ext cx="3520440" cy="1188720"/>
           </a:xfrm>
           <a:prstGeom prst="rect">
             <a:avLst/>
@@ -7194,7 +7214,7 @@
                 <a:ea typeface="Arial" pitchFamily="34" charset="-122"/>
                 <a:cs typeface="Arial" pitchFamily="34" charset="-120"/>
               </a:rPr>
-              <a:t>SAM.gov registration, capability statements, government contracting. Pinnacle helps with business growth.</a:t>
+              <a:t>Grades dropping. Behavior changing. The school sees attendance — but the ecosystem sees WHY. Mom's cancer, the pregnancy, the stress at home. ISSS wraps supports around the child.</a:t>
             </a:r>
             <a:endParaRPr lang="en-US" sz="1000" dirty="0"/>
           </a:p>
@@ -7208,12 +7228,12 @@
         </p:nvSpPr>
         <p:spPr>
           <a:xfrm>
-            <a:off x="8046720" y="4983480"/>
-            <a:ext cx="3703320" cy="1691640"/>
+            <a:off x="8046720" y="4892040"/>
+            <a:ext cx="3703320" cy="1783080"/>
           </a:xfrm>
           <a:prstGeom prst="roundRect">
             <a:avLst>
-              <a:gd name="adj" fmla="val 4324"/>
+              <a:gd name="adj" fmla="val 4103"/>
             </a:avLst>
           </a:prstGeom>
           <a:solidFill>
@@ -7235,24 +7255,24 @@
         </p:nvSpPr>
         <p:spPr>
           <a:xfrm>
-            <a:off x="8138160" y="5010912"/>
-            <a:ext cx="1737360" cy="320040"/>
-          </a:xfrm>
-          <a:prstGeom prst="rect">
-            <a:avLst/>
-          </a:prstGeom>
-          <a:noFill/>
-          <a:ln/>
-        </p:spPr>
-        <p:txBody>
-          <a:bodyPr wrap="square" rtlCol="0" anchor="ctr"/>
-          <a:lstStyle/>
-          <a:p>
-            <a:pPr indent="0" marL="0">
-              <a:buNone/>
-            </a:pPr>
-            <a:r>
-              <a:rPr lang="en-US" sz="1100" b="1" dirty="0">
+            <a:off x="8138160" y="4919472"/>
+            <a:ext cx="2011680" cy="320040"/>
+          </a:xfrm>
+          <a:prstGeom prst="rect">
+            <a:avLst/>
+          </a:prstGeom>
+          <a:noFill/>
+          <a:ln/>
+        </p:spPr>
+        <p:txBody>
+          <a:bodyPr wrap="square" rtlCol="0" anchor="ctr"/>
+          <a:lstStyle/>
+          <a:p>
+            <a:pPr indent="0" marL="0">
+              <a:buNone/>
+            </a:pPr>
+            <a:r>
+              <a:rPr lang="en-US" sz="1200" b="1" dirty="0">
                 <a:solidFill>
                   <a:srgbClr val="00C9A7"/>
                 </a:solidFill>
@@ -7260,9 +7280,9 @@
                 <a:ea typeface="Arial" pitchFamily="34" charset="-122"/>
                 <a:cs typeface="Arial" pitchFamily="34" charset="-120"/>
               </a:rPr>
-              <a:t>She needs resources.</a:t>
-            </a:r>
-            <a:endParaRPr lang="en-US" sz="1100" dirty="0"/>
+              <a:t>She runs a nonprofit.</a:t>
+            </a:r>
+            <a:endParaRPr lang="en-US" sz="1200" dirty="0"/>
           </a:p>
         </p:txBody>
       </p:sp>
@@ -7274,8 +7294,8 @@
         </p:nvSpPr>
         <p:spPr>
           <a:xfrm>
-            <a:off x="9875520" y="5010912"/>
-            <a:ext cx="1783080" cy="320040"/>
+            <a:off x="10058400" y="4919472"/>
+            <a:ext cx="1600200" cy="320040"/>
           </a:xfrm>
           <a:prstGeom prst="rect">
             <a:avLst/>
@@ -7291,7 +7311,7 @@
               <a:buNone/>
             </a:pPr>
             <a:r>
-              <a:rPr lang="en-US" sz="1100" b="1" dirty="0">
+              <a:rPr lang="en-US" sz="1050" b="1" dirty="0">
                 <a:solidFill>
                   <a:srgbClr val="FFFFFF"/>
                 </a:solidFill>
@@ -7299,9 +7319,9 @@
                 <a:ea typeface="Arial" pitchFamily="34" charset="-122"/>
                 <a:cs typeface="Arial" pitchFamily="34" charset="-120"/>
               </a:rPr>
-              <a:t>Collaborative Advocate</a:t>
-            </a:r>
-            <a:endParaRPr lang="en-US" sz="1100" dirty="0"/>
+              <a:t>Minority CoE + Advocate</a:t>
+            </a:r>
+            <a:endParaRPr lang="en-US" sz="1050" dirty="0"/>
           </a:p>
         </p:txBody>
       </p:sp>
@@ -7313,8 +7333,8 @@
         </p:nvSpPr>
         <p:spPr>
           <a:xfrm>
-            <a:off x="8229600" y="5349240"/>
-            <a:ext cx="3337560" cy="18288"/>
+            <a:off x="8183880" y="5257800"/>
+            <a:ext cx="3429000" cy="18288"/>
           </a:xfrm>
           <a:prstGeom prst="rect">
             <a:avLst/>
@@ -7333,8 +7353,8 @@
         </p:nvSpPr>
         <p:spPr>
           <a:xfrm>
-            <a:off x="8138160" y="5440680"/>
-            <a:ext cx="3520440" cy="1097280"/>
+            <a:off x="8138160" y="5349240"/>
+            <a:ext cx="3520440" cy="1188720"/>
           </a:xfrm>
           <a:prstGeom prst="rect">
             <a:avLst/>
@@ -7361,7 +7381,7 @@
                 <a:ea typeface="Arial" pitchFamily="34" charset="-122"/>
                 <a:cs typeface="Arial" pitchFamily="34" charset="-120"/>
               </a:rPr>
-              <a:t>Legal aid, benefits enrollment, housing navigation, childcare. LexiBridge if she needs it in another language.</a:t>
+              <a:t>Business continuity during crisis. Benefits, legal aid, housing, childcare, transportation to twice as many appointments.</a:t>
             </a:r>
             <a:endParaRPr lang="en-US" sz="1000" dirty="0"/>
           </a:p>
@@ -7401,7 +7421,27 @@
       </p:grpSpPr>
       <p:sp>
         <p:nvSpPr>
-          <p:cNvPr id="2" name="Text 0"/>
+          <p:cNvPr id="2" name="Shape 0"/>
+          <p:cNvSpPr/>
+          <p:nvPr/>
+        </p:nvSpPr>
+        <p:spPr>
+          <a:xfrm>
+            <a:off x="0" y="0"/>
+            <a:ext cx="12188952" cy="109728"/>
+          </a:xfrm>
+          <a:prstGeom prst="rect">
+            <a:avLst/>
+          </a:prstGeom>
+          <a:solidFill>
+            <a:srgbClr val="E8459E"/>
+          </a:solidFill>
+          <a:ln/>
+        </p:spPr>
+      </p:sp>
+      <p:sp>
+        <p:nvSpPr>
+          <p:cNvPr id="3" name="Text 1"/>
           <p:cNvSpPr/>
           <p:nvPr/>
         </p:nvSpPr>
@@ -7426,13 +7466,13 @@
             <a:r>
               <a:rPr lang="en-US" sz="1300" b="1" dirty="0">
                 <a:solidFill>
-                  <a:srgbClr val="F97316"/>
-                </a:solidFill>
-                <a:latin typeface="Arial" pitchFamily="34" charset="0"/>
-                <a:ea typeface="Arial" pitchFamily="34" charset="-122"/>
-                <a:cs typeface="Arial" pitchFamily="34" charset="-120"/>
-              </a:rPr>
-              <a:t>The Ecosystem in Motion</a:t>
+                  <a:srgbClr val="E8459E"/>
+                </a:solidFill>
+                <a:latin typeface="Arial" pitchFamily="34" charset="0"/>
+                <a:ea typeface="Arial" pitchFamily="34" charset="-122"/>
+                <a:cs typeface="Arial" pitchFamily="34" charset="-120"/>
+              </a:rPr>
+              <a:t>When Domains Collide</a:t>
             </a:r>
             <a:endParaRPr lang="en-US" sz="1300" dirty="0"/>
           </a:p>
@@ -7440,7 +7480,7 @@
       </p:sp>
       <p:sp>
         <p:nvSpPr>
-          <p:cNvPr id="3" name="Text 1"/>
+          <p:cNvPr id="4" name="Text 2"/>
           <p:cNvSpPr/>
           <p:nvPr/>
         </p:nvSpPr>
@@ -7474,7 +7514,7 @@
                 <a:ea typeface="Arial" pitchFamily="34" charset="-122"/>
                 <a:cs typeface="Arial" pitchFamily="34" charset="-120"/>
               </a:rPr>
-              <a:t>What Happens When Life Hits —</a:t>
+              <a:t>Pregnant During Cancer Treatment.</a:t>
             </a:r>
             <a:endParaRPr lang="en-US" sz="3300" dirty="0"/>
           </a:p>
@@ -7494,7 +7534,7 @@
                 <a:ea typeface="Arial" pitchFamily="34" charset="-122"/>
                 <a:cs typeface="Arial" pitchFamily="34" charset="-120"/>
               </a:rPr>
-              <a:t>And Every Platform Responds</a:t>
+              <a:t>Child Falling Behind. Everything Connected.</a:t>
             </a:r>
             <a:endParaRPr lang="en-US" sz="3300" dirty="0"/>
           </a:p>
@@ -7502,14 +7542,14 @@
       </p:sp>
       <p:sp>
         <p:nvSpPr>
-          <p:cNvPr id="4" name="Text 2"/>
+          <p:cNvPr id="5" name="Text 3"/>
           <p:cNvSpPr/>
           <p:nvPr/>
         </p:nvSpPr>
         <p:spPr>
           <a:xfrm>
             <a:off x="731520" y="1874520"/>
-            <a:ext cx="10515600" cy="640080"/>
+            <a:ext cx="10515600" cy="777240"/>
           </a:xfrm>
           <a:prstGeom prst="rect">
             <a:avLst/>
@@ -7523,12 +7563,12 @@
           <a:p>
             <a:pPr indent="0" marL="0">
               <a:lnSpc>
-                <a:spcPct val="135000"/>
+                <a:spcPct val="140000"/>
               </a:lnSpc>
               <a:buNone/>
             </a:pPr>
             <a:r>
-              <a:rPr lang="en-US" sz="1300" i="1" dirty="0">
+              <a:rPr lang="en-US" sz="1250" dirty="0">
                 <a:solidFill>
                   <a:srgbClr val="8B949E"/>
                 </a:solidFill>
@@ -7536,21 +7576,188 @@
                 <a:ea typeface="Arial" pitchFamily="34" charset="-122"/>
                 <a:cs typeface="Arial" pitchFamily="34" charset="-120"/>
               </a:rPr>
-              <a:t>Keisha is 6 months into her cancer treatment. Her depression worsens. She can't work full-time. Her nonprofit is struggling. Her daughter's grades are dropping. In a disconnected system, each of these is a separate crisis handled by a separate agency. In ThriveUp:</a:t>
-            </a:r>
-            <a:endParaRPr lang="en-US" sz="1300" dirty="0"/>
-          </a:p>
-        </p:txBody>
-      </p:sp>
-      <p:sp>
-        <p:nvSpPr>
-          <p:cNvPr id="5" name="Shape 3"/>
-          <p:cNvSpPr/>
-          <p:nvPr/>
-        </p:nvSpPr>
-        <p:spPr>
-          <a:xfrm>
-            <a:off x="274320" y="2697480"/>
+              <a:t>This is the moment that proves why disconnected systems fail. Keisha's cancer treatment, her pregnancy, her depression, and her child's grades are all one crisis — caused by the same root: a family under pressure with no connected support. The school sees attendance. The hospital sees labs. Nobody sees the family. Except ThriveUp:</a:t>
+            </a:r>
+            <a:endParaRPr lang="en-US" sz="1250" dirty="0"/>
+          </a:p>
+        </p:txBody>
+      </p:sp>
+      <p:sp>
+        <p:nvSpPr>
+          <p:cNvPr id="6" name="Shape 4"/>
+          <p:cNvSpPr/>
+          <p:nvPr/>
+        </p:nvSpPr>
+        <p:spPr>
+          <a:xfrm>
+            <a:off x="274320" y="2834640"/>
+            <a:ext cx="3703320" cy="1874520"/>
+          </a:xfrm>
+          <a:prstGeom prst="roundRect">
+            <a:avLst>
+              <a:gd name="adj" fmla="val 3902"/>
+            </a:avLst>
+          </a:prstGeom>
+          <a:solidFill>
+            <a:srgbClr val="161B22"/>
+          </a:solidFill>
+          <a:ln w="19050">
+            <a:solidFill>
+              <a:srgbClr val="E8459E"/>
+            </a:solidFill>
+            <a:prstDash val="solid"/>
+          </a:ln>
+        </p:spPr>
+      </p:sp>
+      <p:sp>
+        <p:nvSpPr>
+          <p:cNvPr id="7" name="Text 5"/>
+          <p:cNvSpPr/>
+          <p:nvPr/>
+        </p:nvSpPr>
+        <p:spPr>
+          <a:xfrm>
+            <a:off x="365760" y="2852928"/>
+            <a:ext cx="2286000" cy="256032"/>
+          </a:xfrm>
+          <a:prstGeom prst="rect">
+            <a:avLst/>
+          </a:prstGeom>
+          <a:noFill/>
+          <a:ln/>
+        </p:spPr>
+        <p:txBody>
+          <a:bodyPr wrap="square" rtlCol="0" anchor="ctr"/>
+          <a:lstStyle/>
+          <a:p>
+            <a:pPr indent="0" marL="0">
+              <a:buNone/>
+            </a:pPr>
+            <a:r>
+              <a:rPr lang="en-US" sz="950" b="1" dirty="0">
+                <a:solidFill>
+                  <a:srgbClr val="E8459E"/>
+                </a:solidFill>
+                <a:latin typeface="Arial" pitchFamily="34" charset="0"/>
+                <a:ea typeface="Arial" pitchFamily="34" charset="-122"/>
+                <a:cs typeface="Arial" pitchFamily="34" charset="-120"/>
+              </a:rPr>
+              <a:t>Sankofa ↔ Maternal Health</a:t>
+            </a:r>
+            <a:endParaRPr lang="en-US" sz="950" dirty="0"/>
+          </a:p>
+        </p:txBody>
+      </p:sp>
+      <p:sp>
+        <p:nvSpPr>
+          <p:cNvPr id="8" name="Text 6"/>
+          <p:cNvSpPr/>
+          <p:nvPr/>
+        </p:nvSpPr>
+        <p:spPr>
+          <a:xfrm>
+            <a:off x="2560320" y="2852928"/>
+            <a:ext cx="1325880" cy="256032"/>
+          </a:xfrm>
+          <a:prstGeom prst="rect">
+            <a:avLst/>
+          </a:prstGeom>
+          <a:noFill/>
+          <a:ln/>
+        </p:spPr>
+        <p:txBody>
+          <a:bodyPr wrap="square" rtlCol="0" anchor="ctr"/>
+          <a:lstStyle/>
+          <a:p>
+            <a:pPr algn="r" indent="0" marL="0">
+              <a:buNone/>
+            </a:pPr>
+            <a:r>
+              <a:rPr lang="en-US" sz="950" b="1" dirty="0">
+                <a:solidFill>
+                  <a:srgbClr val="FFFFFF"/>
+                </a:solidFill>
+                <a:latin typeface="Arial" pitchFamily="34" charset="0"/>
+                <a:ea typeface="Arial" pitchFamily="34" charset="-122"/>
+                <a:cs typeface="Arial" pitchFamily="34" charset="-120"/>
+              </a:rPr>
+              <a:t>Cancer Meets Pregnancy</a:t>
+            </a:r>
+            <a:endParaRPr lang="en-US" sz="950" dirty="0"/>
+          </a:p>
+        </p:txBody>
+      </p:sp>
+      <p:sp>
+        <p:nvSpPr>
+          <p:cNvPr id="9" name="Shape 7"/>
+          <p:cNvSpPr/>
+          <p:nvPr/>
+        </p:nvSpPr>
+        <p:spPr>
+          <a:xfrm>
+            <a:off x="411480" y="3136392"/>
+            <a:ext cx="3429000" cy="18288"/>
+          </a:xfrm>
+          <a:prstGeom prst="rect">
+            <a:avLst/>
+          </a:prstGeom>
+          <a:solidFill>
+            <a:srgbClr val="E8459E"/>
+          </a:solidFill>
+          <a:ln/>
+        </p:spPr>
+      </p:sp>
+      <p:sp>
+        <p:nvSpPr>
+          <p:cNvPr id="10" name="Text 8"/>
+          <p:cNvSpPr/>
+          <p:nvPr/>
+        </p:nvSpPr>
+        <p:spPr>
+          <a:xfrm>
+            <a:off x="365760" y="3200400"/>
+            <a:ext cx="3520440" cy="1371600"/>
+          </a:xfrm>
+          <a:prstGeom prst="rect">
+            <a:avLst/>
+          </a:prstGeom>
+          <a:noFill/>
+          <a:ln/>
+        </p:spPr>
+        <p:txBody>
+          <a:bodyPr wrap="square" rtlCol="0" anchor="ctr"/>
+          <a:lstStyle/>
+          <a:p>
+            <a:pPr indent="0" marL="0">
+              <a:lnSpc>
+                <a:spcPct val="125000"/>
+              </a:lnSpc>
+              <a:buNone/>
+            </a:pPr>
+            <a:r>
+              <a:rPr lang="en-US" sz="950" dirty="0">
+                <a:solidFill>
+                  <a:srgbClr val="8B949E"/>
+                </a:solidFill>
+                <a:latin typeface="Arial" pitchFamily="34" charset="0"/>
+                <a:ea typeface="Arial" pitchFamily="34" charset="-122"/>
+                <a:cs typeface="Arial" pitchFamily="34" charset="-120"/>
+              </a:rPr>
+              <a:t>Keisha's pregnancy is confirmed during chemo. Sankofa alerts Black Maternal Health Network instantly. Both platforms see the full picture — treatment protocol, gestational age, risk factors. Her oncologist and OB work from the SAME record. Not separate charts that never cross.</a:t>
+            </a:r>
+            <a:endParaRPr lang="en-US" sz="950" dirty="0"/>
+          </a:p>
+        </p:txBody>
+      </p:sp>
+      <p:sp>
+        <p:nvSpPr>
+          <p:cNvPr id="11" name="Shape 9"/>
+          <p:cNvSpPr/>
+          <p:nvPr/>
+        </p:nvSpPr>
+        <p:spPr>
+          <a:xfrm>
+            <a:off x="4160520" y="2834640"/>
             <a:ext cx="3703320" cy="1874520"/>
           </a:xfrm>
           <a:prstGeom prst="roundRect">
@@ -7571,30 +7778,30 @@
       </p:sp>
       <p:sp>
         <p:nvSpPr>
-          <p:cNvPr id="6" name="Text 4"/>
-          <p:cNvSpPr/>
-          <p:nvPr/>
-        </p:nvSpPr>
-        <p:spPr>
-          <a:xfrm>
-            <a:off x="365760" y="2724912"/>
-            <a:ext cx="3520440" cy="320040"/>
-          </a:xfrm>
-          <a:prstGeom prst="rect">
-            <a:avLst/>
-          </a:prstGeom>
-          <a:noFill/>
-          <a:ln/>
-        </p:spPr>
-        <p:txBody>
-          <a:bodyPr wrap="square" rtlCol="0" anchor="ctr"/>
-          <a:lstStyle/>
-          <a:p>
-            <a:pPr indent="0" marL="0">
-              <a:buNone/>
-            </a:pPr>
-            <a:r>
-              <a:rPr lang="en-US" sz="1200" b="1" dirty="0">
+          <p:cNvPr id="12" name="Text 10"/>
+          <p:cNvSpPr/>
+          <p:nvPr/>
+        </p:nvSpPr>
+        <p:spPr>
+          <a:xfrm>
+            <a:off x="4251960" y="2852928"/>
+            <a:ext cx="2286000" cy="256032"/>
+          </a:xfrm>
+          <a:prstGeom prst="rect">
+            <a:avLst/>
+          </a:prstGeom>
+          <a:noFill/>
+          <a:ln/>
+        </p:spPr>
+        <p:txBody>
+          <a:bodyPr wrap="square" rtlCol="0" anchor="ctr"/>
+          <a:lstStyle/>
+          <a:p>
+            <a:pPr indent="0" marL="0">
+              <a:buNone/>
+            </a:pPr>
+            <a:r>
+              <a:rPr lang="en-US" sz="950" b="1" dirty="0">
                 <a:solidFill>
                   <a:srgbClr val="8B5CF6"/>
                 </a:solidFill>
@@ -7602,61 +7809,61 @@
                 <a:ea typeface="Arial" pitchFamily="34" charset="-122"/>
                 <a:cs typeface="Arial" pitchFamily="34" charset="-120"/>
               </a:rPr>
-              <a:t>Cancer treatment intensifies</a:t>
-            </a:r>
-            <a:endParaRPr lang="en-US" sz="1200" dirty="0"/>
-          </a:p>
-        </p:txBody>
-      </p:sp>
-      <p:sp>
-        <p:nvSpPr>
-          <p:cNvPr id="7" name="Text 5"/>
-          <p:cNvSpPr/>
-          <p:nvPr/>
-        </p:nvSpPr>
-        <p:spPr>
-          <a:xfrm>
-            <a:off x="365760" y="3017520"/>
-            <a:ext cx="3520440" cy="228600"/>
-          </a:xfrm>
-          <a:prstGeom prst="rect">
-            <a:avLst/>
-          </a:prstGeom>
-          <a:noFill/>
-          <a:ln/>
-        </p:spPr>
-        <p:txBody>
-          <a:bodyPr wrap="square" rtlCol="0" anchor="ctr"/>
-          <a:lstStyle/>
-          <a:p>
-            <a:pPr indent="0" marL="0">
-              <a:buNone/>
-            </a:pPr>
-            <a:r>
-              <a:rPr lang="en-US" sz="900" b="1" i="1" dirty="0">
-                <a:solidFill>
-                  <a:srgbClr val="8B5CF6"/>
-                </a:solidFill>
-                <a:latin typeface="Arial" pitchFamily="34" charset="0"/>
-                <a:ea typeface="Arial" pitchFamily="34" charset="-122"/>
-                <a:cs typeface="Arial" pitchFamily="34" charset="-120"/>
-              </a:rPr>
-              <a:t>Health → Behavioral Health</a:t>
-            </a:r>
-            <a:endParaRPr lang="en-US" sz="900" dirty="0"/>
-          </a:p>
-        </p:txBody>
-      </p:sp>
-      <p:sp>
-        <p:nvSpPr>
-          <p:cNvPr id="8" name="Shape 6"/>
-          <p:cNvSpPr/>
-          <p:nvPr/>
-        </p:nvSpPr>
-        <p:spPr>
-          <a:xfrm>
-            <a:off x="457200" y="3246120"/>
-            <a:ext cx="3337560" cy="18288"/>
+              <a:t>Behavioral Health</a:t>
+            </a:r>
+            <a:endParaRPr lang="en-US" sz="950" dirty="0"/>
+          </a:p>
+        </p:txBody>
+      </p:sp>
+      <p:sp>
+        <p:nvSpPr>
+          <p:cNvPr id="13" name="Text 11"/>
+          <p:cNvSpPr/>
+          <p:nvPr/>
+        </p:nvSpPr>
+        <p:spPr>
+          <a:xfrm>
+            <a:off x="6446520" y="2852928"/>
+            <a:ext cx="1325880" cy="256032"/>
+          </a:xfrm>
+          <a:prstGeom prst="rect">
+            <a:avLst/>
+          </a:prstGeom>
+          <a:noFill/>
+          <a:ln/>
+        </p:spPr>
+        <p:txBody>
+          <a:bodyPr wrap="square" rtlCol="0" anchor="ctr"/>
+          <a:lstStyle/>
+          <a:p>
+            <a:pPr algn="r" indent="0" marL="0">
+              <a:buNone/>
+            </a:pPr>
+            <a:r>
+              <a:rPr lang="en-US" sz="950" b="1" dirty="0">
+                <a:solidFill>
+                  <a:srgbClr val="FFFFFF"/>
+                </a:solidFill>
+                <a:latin typeface="Arial" pitchFamily="34" charset="0"/>
+                <a:ea typeface="Arial" pitchFamily="34" charset="-122"/>
+                <a:cs typeface="Arial" pitchFamily="34" charset="-120"/>
+              </a:rPr>
+              <a:t>Mental Health Emergency</a:t>
+            </a:r>
+            <a:endParaRPr lang="en-US" sz="950" dirty="0"/>
+          </a:p>
+        </p:txBody>
+      </p:sp>
+      <p:sp>
+        <p:nvSpPr>
+          <p:cNvPr id="14" name="Shape 12"/>
+          <p:cNvSpPr/>
+          <p:nvPr/>
+        </p:nvSpPr>
+        <p:spPr>
+          <a:xfrm>
+            <a:off x="4297680" y="3136392"/>
+            <a:ext cx="3429000" cy="18288"/>
           </a:xfrm>
           <a:prstGeom prst="rect">
             <a:avLst/>
@@ -7669,14 +7876,14 @@
       </p:sp>
       <p:sp>
         <p:nvSpPr>
-          <p:cNvPr id="9" name="Text 7"/>
-          <p:cNvSpPr/>
-          <p:nvPr/>
-        </p:nvSpPr>
-        <p:spPr>
-          <a:xfrm>
-            <a:off x="365760" y="3337560"/>
-            <a:ext cx="3520440" cy="1097280"/>
+          <p:cNvPr id="15" name="Text 13"/>
+          <p:cNvSpPr/>
+          <p:nvPr/>
+        </p:nvSpPr>
+        <p:spPr>
+          <a:xfrm>
+            <a:off x="4251960" y="3200400"/>
+            <a:ext cx="3520440" cy="1371600"/>
           </a:xfrm>
           <a:prstGeom prst="rect">
             <a:avLst/>
@@ -7690,12 +7897,12 @@
           <a:p>
             <a:pPr indent="0" marL="0">
               <a:lnSpc>
-                <a:spcPct val="130000"/>
+                <a:spcPct val="125000"/>
               </a:lnSpc>
               <a:buNone/>
             </a:pPr>
             <a:r>
-              <a:rPr lang="en-US" sz="1000" dirty="0">
+              <a:rPr lang="en-US" sz="950" dirty="0">
                 <a:solidFill>
                   <a:srgbClr val="8B949E"/>
                 </a:solidFill>
@@ -7703,21 +7910,21 @@
                 <a:ea typeface="Arial" pitchFamily="34" charset="-122"/>
                 <a:cs typeface="Arial" pitchFamily="34" charset="-120"/>
               </a:rPr>
-              <a:t>Sankofa Health alerts her behavioral health provider. PillScheduler adjusts medication tracking. SafeCogniCare monitors cognitive impact of chemo.</a:t>
-            </a:r>
-            <a:endParaRPr lang="en-US" sz="1000" dirty="0"/>
-          </a:p>
-        </p:txBody>
-      </p:sp>
-      <p:sp>
-        <p:nvSpPr>
-          <p:cNvPr id="10" name="Shape 8"/>
-          <p:cNvSpPr/>
-          <p:nvPr/>
-        </p:nvSpPr>
-        <p:spPr>
-          <a:xfrm>
-            <a:off x="4160520" y="2697480"/>
+              <a:t>Cancer + high-risk pregnancy + single parenting = crisis. Whole-Person Health auto-escalates. Her counselor is notified. PillScheduler flags every medication for pregnancy safety — antidepressants, chemo drugs, prenatal vitamins. Everything checked against everything.</a:t>
+            </a:r>
+            <a:endParaRPr lang="en-US" sz="950" dirty="0"/>
+          </a:p>
+        </p:txBody>
+      </p:sp>
+      <p:sp>
+        <p:nvSpPr>
+          <p:cNvPr id="16" name="Shape 14"/>
+          <p:cNvSpPr/>
+          <p:nvPr/>
+        </p:nvSpPr>
+        <p:spPr>
+          <a:xfrm>
+            <a:off x="8046720" y="2834640"/>
             <a:ext cx="3703320" cy="1874520"/>
           </a:xfrm>
           <a:prstGeom prst="roundRect">
@@ -7730,7 +7937,7 @@
           </a:solidFill>
           <a:ln w="19050">
             <a:solidFill>
-              <a:srgbClr val="E8459E"/>
+              <a:srgbClr val="F0B429"/>
             </a:solidFill>
             <a:prstDash val="solid"/>
           </a:ln>
@@ -7738,112 +7945,112 @@
       </p:sp>
       <p:sp>
         <p:nvSpPr>
-          <p:cNvPr id="11" name="Text 9"/>
-          <p:cNvSpPr/>
-          <p:nvPr/>
-        </p:nvSpPr>
-        <p:spPr>
-          <a:xfrm>
-            <a:off x="4251960" y="2724912"/>
-            <a:ext cx="3520440" cy="320040"/>
-          </a:xfrm>
-          <a:prstGeom prst="rect">
-            <a:avLst/>
-          </a:prstGeom>
-          <a:noFill/>
-          <a:ln/>
-        </p:spPr>
-        <p:txBody>
-          <a:bodyPr wrap="square" rtlCol="0" anchor="ctr"/>
-          <a:lstStyle/>
-          <a:p>
-            <a:pPr indent="0" marL="0">
-              <a:buNone/>
-            </a:pPr>
-            <a:r>
-              <a:rPr lang="en-US" sz="1200" b="1" dirty="0">
-                <a:solidFill>
-                  <a:srgbClr val="E8459E"/>
-                </a:solidFill>
-                <a:latin typeface="Arial" pitchFamily="34" charset="0"/>
-                <a:ea typeface="Arial" pitchFamily="34" charset="-122"/>
-                <a:cs typeface="Arial" pitchFamily="34" charset="-120"/>
-              </a:rPr>
-              <a:t>Depression worsens</a:t>
-            </a:r>
-            <a:endParaRPr lang="en-US" sz="1200" dirty="0"/>
-          </a:p>
-        </p:txBody>
-      </p:sp>
-      <p:sp>
-        <p:nvSpPr>
-          <p:cNvPr id="12" name="Text 10"/>
-          <p:cNvSpPr/>
-          <p:nvPr/>
-        </p:nvSpPr>
-        <p:spPr>
-          <a:xfrm>
-            <a:off x="4251960" y="3017520"/>
-            <a:ext cx="3520440" cy="228600"/>
-          </a:xfrm>
-          <a:prstGeom prst="rect">
-            <a:avLst/>
-          </a:prstGeom>
-          <a:noFill/>
-          <a:ln/>
-        </p:spPr>
-        <p:txBody>
-          <a:bodyPr wrap="square" rtlCol="0" anchor="ctr"/>
-          <a:lstStyle/>
-          <a:p>
-            <a:pPr indent="0" marL="0">
-              <a:buNone/>
-            </a:pPr>
-            <a:r>
-              <a:rPr lang="en-US" sz="900" b="1" i="1" dirty="0">
-                <a:solidFill>
-                  <a:srgbClr val="E8459E"/>
-                </a:solidFill>
-                <a:latin typeface="Arial" pitchFamily="34" charset="0"/>
-                <a:ea typeface="Arial" pitchFamily="34" charset="-122"/>
-                <a:cs typeface="Arial" pitchFamily="34" charset="-120"/>
-              </a:rPr>
-              <a:t>Behavioral Health → Crisis</a:t>
-            </a:r>
-            <a:endParaRPr lang="en-US" sz="900" dirty="0"/>
-          </a:p>
-        </p:txBody>
-      </p:sp>
-      <p:sp>
-        <p:nvSpPr>
-          <p:cNvPr id="13" name="Shape 11"/>
-          <p:cNvSpPr/>
-          <p:nvPr/>
-        </p:nvSpPr>
-        <p:spPr>
-          <a:xfrm>
-            <a:off x="4343400" y="3246120"/>
-            <a:ext cx="3337560" cy="18288"/>
+          <p:cNvPr id="17" name="Text 15"/>
+          <p:cNvSpPr/>
+          <p:nvPr/>
+        </p:nvSpPr>
+        <p:spPr>
+          <a:xfrm>
+            <a:off x="8138160" y="2852928"/>
+            <a:ext cx="2286000" cy="256032"/>
+          </a:xfrm>
+          <a:prstGeom prst="rect">
+            <a:avLst/>
+          </a:prstGeom>
+          <a:noFill/>
+          <a:ln/>
+        </p:spPr>
+        <p:txBody>
+          <a:bodyPr wrap="square" rtlCol="0" anchor="ctr"/>
+          <a:lstStyle/>
+          <a:p>
+            <a:pPr indent="0" marL="0">
+              <a:buNone/>
+            </a:pPr>
+            <a:r>
+              <a:rPr lang="en-US" sz="950" b="1" dirty="0">
+                <a:solidFill>
+                  <a:srgbClr val="F0B429"/>
+                </a:solidFill>
+                <a:latin typeface="Arial" pitchFamily="34" charset="0"/>
+                <a:ea typeface="Arial" pitchFamily="34" charset="-122"/>
+                <a:cs typeface="Arial" pitchFamily="34" charset="-120"/>
+              </a:rPr>
+              <a:t>ISSS + ThriveUp Academy</a:t>
+            </a:r>
+            <a:endParaRPr lang="en-US" sz="950" dirty="0"/>
+          </a:p>
+        </p:txBody>
+      </p:sp>
+      <p:sp>
+        <p:nvSpPr>
+          <p:cNvPr id="18" name="Text 16"/>
+          <p:cNvSpPr/>
+          <p:nvPr/>
+        </p:nvSpPr>
+        <p:spPr>
+          <a:xfrm>
+            <a:off x="10332720" y="2852928"/>
+            <a:ext cx="1325880" cy="256032"/>
+          </a:xfrm>
+          <a:prstGeom prst="rect">
+            <a:avLst/>
+          </a:prstGeom>
+          <a:noFill/>
+          <a:ln/>
+        </p:spPr>
+        <p:txBody>
+          <a:bodyPr wrap="square" rtlCol="0" anchor="ctr"/>
+          <a:lstStyle/>
+          <a:p>
+            <a:pPr algn="r" indent="0" marL="0">
+              <a:buNone/>
+            </a:pPr>
+            <a:r>
+              <a:rPr lang="en-US" sz="950" b="1" dirty="0">
+                <a:solidFill>
+                  <a:srgbClr val="FFFFFF"/>
+                </a:solidFill>
+                <a:latin typeface="Arial" pitchFamily="34" charset="0"/>
+                <a:ea typeface="Arial" pitchFamily="34" charset="-122"/>
+                <a:cs typeface="Arial" pitchFamily="34" charset="-120"/>
+              </a:rPr>
+              <a:t>The Child Nobody Asked About</a:t>
+            </a:r>
+            <a:endParaRPr lang="en-US" sz="950" dirty="0"/>
+          </a:p>
+        </p:txBody>
+      </p:sp>
+      <p:sp>
+        <p:nvSpPr>
+          <p:cNvPr id="19" name="Shape 17"/>
+          <p:cNvSpPr/>
+          <p:nvPr/>
+        </p:nvSpPr>
+        <p:spPr>
+          <a:xfrm>
+            <a:off x="8183880" y="3136392"/>
+            <a:ext cx="3429000" cy="18288"/>
           </a:xfrm>
           <a:prstGeom prst="rect">
             <a:avLst/>
           </a:prstGeom>
           <a:solidFill>
-            <a:srgbClr val="E8459E"/>
+            <a:srgbClr val="F0B429"/>
           </a:solidFill>
           <a:ln/>
         </p:spPr>
       </p:sp>
       <p:sp>
         <p:nvSpPr>
-          <p:cNvPr id="14" name="Text 12"/>
-          <p:cNvSpPr/>
-          <p:nvPr/>
-        </p:nvSpPr>
-        <p:spPr>
-          <a:xfrm>
-            <a:off x="4251960" y="3337560"/>
-            <a:ext cx="3520440" cy="1097280"/>
+          <p:cNvPr id="20" name="Text 18"/>
+          <p:cNvSpPr/>
+          <p:nvPr/>
+        </p:nvSpPr>
+        <p:spPr>
+          <a:xfrm>
+            <a:off x="8138160" y="3200400"/>
+            <a:ext cx="3520440" cy="1371600"/>
           </a:xfrm>
           <a:prstGeom prst="rect">
             <a:avLst/>
@@ -7857,12 +8064,12 @@
           <a:p>
             <a:pPr indent="0" marL="0">
               <a:lnSpc>
-                <a:spcPct val="130000"/>
+                <a:spcPct val="125000"/>
               </a:lnSpc>
               <a:buNone/>
             </a:pPr>
             <a:r>
-              <a:rPr lang="en-US" sz="1000" dirty="0">
+              <a:rPr lang="en-US" sz="950" dirty="0">
                 <a:solidFill>
                   <a:srgbClr val="8B949E"/>
                 </a:solidFill>
@@ -7870,21 +8077,188 @@
                 <a:ea typeface="Arial" pitchFamily="34" charset="-122"/>
                 <a:cs typeface="Arial" pitchFamily="34" charset="-120"/>
               </a:rPr>
-              <a:t>Whole-Person Health flags it. Her counselor is notified. WholeMind Learning provides coping resources. If she's in crisis — the ecosystem knows before she calls a hotline.</a:t>
-            </a:r>
-            <a:endParaRPr lang="en-US" sz="1000" dirty="0"/>
-          </a:p>
-        </p:txBody>
-      </p:sp>
-      <p:sp>
-        <p:nvSpPr>
-          <p:cNvPr id="15" name="Shape 13"/>
-          <p:cNvSpPr/>
-          <p:nvPr/>
-        </p:nvSpPr>
-        <p:spPr>
-          <a:xfrm>
-            <a:off x="8046720" y="2697480"/>
+              <a:t>Her daughter's grades drop from B's to D's. Attendance slips. The school sees a struggling student. The ECOSYSTEM sees: mom has cancer, is pregnant, can't help with homework, can't drive to school events, is exhausted from treatment. ISSS wraps tutoring, mentoring, counseling, and after-school support around the child — because it knows WHY she's struggling.</a:t>
+            </a:r>
+            <a:endParaRPr lang="en-US" sz="950" dirty="0"/>
+          </a:p>
+        </p:txBody>
+      </p:sp>
+      <p:sp>
+        <p:nvSpPr>
+          <p:cNvPr id="21" name="Shape 19"/>
+          <p:cNvSpPr/>
+          <p:nvPr/>
+        </p:nvSpPr>
+        <p:spPr>
+          <a:xfrm>
+            <a:off x="274320" y="4892040"/>
+            <a:ext cx="3703320" cy="1874520"/>
+          </a:xfrm>
+          <a:prstGeom prst="roundRect">
+            <a:avLst>
+              <a:gd name="adj" fmla="val 3902"/>
+            </a:avLst>
+          </a:prstGeom>
+          <a:solidFill>
+            <a:srgbClr val="161B22"/>
+          </a:solidFill>
+          <a:ln w="19050">
+            <a:solidFill>
+              <a:srgbClr val="F97316"/>
+            </a:solidFill>
+            <a:prstDash val="solid"/>
+          </a:ln>
+        </p:spPr>
+      </p:sp>
+      <p:sp>
+        <p:nvSpPr>
+          <p:cNvPr id="22" name="Text 20"/>
+          <p:cNvSpPr/>
+          <p:nvPr/>
+        </p:nvSpPr>
+        <p:spPr>
+          <a:xfrm>
+            <a:off x="365760" y="4910328"/>
+            <a:ext cx="2286000" cy="256032"/>
+          </a:xfrm>
+          <a:prstGeom prst="rect">
+            <a:avLst/>
+          </a:prstGeom>
+          <a:noFill/>
+          <a:ln/>
+        </p:spPr>
+        <p:txBody>
+          <a:bodyPr wrap="square" rtlCol="0" anchor="ctr"/>
+          <a:lstStyle/>
+          <a:p>
+            <a:pPr indent="0" marL="0">
+              <a:buNone/>
+            </a:pPr>
+            <a:r>
+              <a:rPr lang="en-US" sz="950" b="1" dirty="0">
+                <a:solidFill>
+                  <a:srgbClr val="F97316"/>
+                </a:solidFill>
+                <a:latin typeface="Arial" pitchFamily="34" charset="0"/>
+                <a:ea typeface="Arial" pitchFamily="34" charset="-122"/>
+                <a:cs typeface="Arial" pitchFamily="34" charset="-120"/>
+              </a:rPr>
+              <a:t>Perfectly Different</a:t>
+            </a:r>
+            <a:endParaRPr lang="en-US" sz="950" dirty="0"/>
+          </a:p>
+        </p:txBody>
+      </p:sp>
+      <p:sp>
+        <p:nvSpPr>
+          <p:cNvPr id="23" name="Text 21"/>
+          <p:cNvSpPr/>
+          <p:nvPr/>
+        </p:nvSpPr>
+        <p:spPr>
+          <a:xfrm>
+            <a:off x="2560320" y="4910328"/>
+            <a:ext cx="1325880" cy="256032"/>
+          </a:xfrm>
+          <a:prstGeom prst="rect">
+            <a:avLst/>
+          </a:prstGeom>
+          <a:noFill/>
+          <a:ln/>
+        </p:spPr>
+        <p:txBody>
+          <a:bodyPr wrap="square" rtlCol="0" anchor="ctr"/>
+          <a:lstStyle/>
+          <a:p>
+            <a:pPr algn="r" indent="0" marL="0">
+              <a:buNone/>
+            </a:pPr>
+            <a:r>
+              <a:rPr lang="en-US" sz="950" b="1" dirty="0">
+                <a:solidFill>
+                  <a:srgbClr val="FFFFFF"/>
+                </a:solidFill>
+                <a:latin typeface="Arial" pitchFamily="34" charset="0"/>
+                <a:ea typeface="Arial" pitchFamily="34" charset="-122"/>
+                <a:cs typeface="Arial" pitchFamily="34" charset="-120"/>
+              </a:rPr>
+              <a:t>Is It More Than Stress?</a:t>
+            </a:r>
+            <a:endParaRPr lang="en-US" sz="950" dirty="0"/>
+          </a:p>
+        </p:txBody>
+      </p:sp>
+      <p:sp>
+        <p:nvSpPr>
+          <p:cNvPr id="24" name="Shape 22"/>
+          <p:cNvSpPr/>
+          <p:nvPr/>
+        </p:nvSpPr>
+        <p:spPr>
+          <a:xfrm>
+            <a:off x="411480" y="5193792"/>
+            <a:ext cx="3429000" cy="18288"/>
+          </a:xfrm>
+          <a:prstGeom prst="rect">
+            <a:avLst/>
+          </a:prstGeom>
+          <a:solidFill>
+            <a:srgbClr val="F97316"/>
+          </a:solidFill>
+          <a:ln/>
+        </p:spPr>
+      </p:sp>
+      <p:sp>
+        <p:nvSpPr>
+          <p:cNvPr id="25" name="Text 23"/>
+          <p:cNvSpPr/>
+          <p:nvPr/>
+        </p:nvSpPr>
+        <p:spPr>
+          <a:xfrm>
+            <a:off x="365760" y="5257800"/>
+            <a:ext cx="3520440" cy="1371600"/>
+          </a:xfrm>
+          <a:prstGeom prst="rect">
+            <a:avLst/>
+          </a:prstGeom>
+          <a:noFill/>
+          <a:ln/>
+        </p:spPr>
+        <p:txBody>
+          <a:bodyPr wrap="square" rtlCol="0" anchor="ctr"/>
+          <a:lstStyle/>
+          <a:p>
+            <a:pPr indent="0" marL="0">
+              <a:lnSpc>
+                <a:spcPct val="125000"/>
+              </a:lnSpc>
+              <a:buNone/>
+            </a:pPr>
+            <a:r>
+              <a:rPr lang="en-US" sz="950" dirty="0">
+                <a:solidFill>
+                  <a:srgbClr val="8B949E"/>
+                </a:solidFill>
+                <a:latin typeface="Arial" pitchFamily="34" charset="0"/>
+                <a:ea typeface="Arial" pitchFamily="34" charset="-122"/>
+                <a:cs typeface="Arial" pitchFamily="34" charset="-120"/>
+              </a:rPr>
+              <a:t>The child's behavioral changes could be emotional — or they could signal something deeper. Perfectly Different screens for learning differences that stress may have unmasked. If she needs an IEP or adaptive support, the platform catches it. The ecosystem doesn't assume — it checks.</a:t>
+            </a:r>
+            <a:endParaRPr lang="en-US" sz="950" dirty="0"/>
+          </a:p>
+        </p:txBody>
+      </p:sp>
+      <p:sp>
+        <p:nvSpPr>
+          <p:cNvPr id="26" name="Shape 24"/>
+          <p:cNvSpPr/>
+          <p:nvPr/>
+        </p:nvSpPr>
+        <p:spPr>
+          <a:xfrm>
+            <a:off x="4160520" y="4892040"/>
             <a:ext cx="3703320" cy="1874520"/>
           </a:xfrm>
           <a:prstGeom prst="roundRect">
@@ -7905,30 +8279,30 @@
       </p:sp>
       <p:sp>
         <p:nvSpPr>
-          <p:cNvPr id="16" name="Text 14"/>
-          <p:cNvSpPr/>
-          <p:nvPr/>
-        </p:nvSpPr>
-        <p:spPr>
-          <a:xfrm>
-            <a:off x="8138160" y="2724912"/>
-            <a:ext cx="3520440" cy="320040"/>
-          </a:xfrm>
-          <a:prstGeom prst="rect">
-            <a:avLst/>
-          </a:prstGeom>
-          <a:noFill/>
-          <a:ln/>
-        </p:spPr>
-        <p:txBody>
-          <a:bodyPr wrap="square" rtlCol="0" anchor="ctr"/>
-          <a:lstStyle/>
-          <a:p>
-            <a:pPr indent="0" marL="0">
-              <a:buNone/>
-            </a:pPr>
-            <a:r>
-              <a:rPr lang="en-US" sz="1200" b="1" dirty="0">
+          <p:cNvPr id="27" name="Text 25"/>
+          <p:cNvSpPr/>
+          <p:nvPr/>
+        </p:nvSpPr>
+        <p:spPr>
+          <a:xfrm>
+            <a:off x="4251960" y="4910328"/>
+            <a:ext cx="2286000" cy="256032"/>
+          </a:xfrm>
+          <a:prstGeom prst="rect">
+            <a:avLst/>
+          </a:prstGeom>
+          <a:noFill/>
+          <a:ln/>
+        </p:spPr>
+        <p:txBody>
+          <a:bodyPr wrap="square" rtlCol="0" anchor="ctr"/>
+          <a:lstStyle/>
+          <a:p>
+            <a:pPr indent="0" marL="0">
+              <a:buNone/>
+            </a:pPr>
+            <a:r>
+              <a:rPr lang="en-US" sz="950" b="1" dirty="0">
                 <a:solidFill>
                   <a:srgbClr val="0079F2"/>
                 </a:solidFill>
@@ -7936,61 +8310,61 @@
                 <a:ea typeface="Arial" pitchFamily="34" charset="-122"/>
                 <a:cs typeface="Arial" pitchFamily="34" charset="-120"/>
               </a:rPr>
-              <a:t>Can't work full-time</a:t>
-            </a:r>
-            <a:endParaRPr lang="en-US" sz="1200" dirty="0"/>
-          </a:p>
-        </p:txBody>
-      </p:sp>
-      <p:sp>
-        <p:nvSpPr>
-          <p:cNvPr id="17" name="Text 15"/>
-          <p:cNvSpPr/>
-          <p:nvPr/>
-        </p:nvSpPr>
-        <p:spPr>
-          <a:xfrm>
-            <a:off x="8138160" y="3017520"/>
-            <a:ext cx="3520440" cy="228600"/>
-          </a:xfrm>
-          <a:prstGeom prst="rect">
-            <a:avLst/>
-          </a:prstGeom>
-          <a:noFill/>
-          <a:ln/>
-        </p:spPr>
-        <p:txBody>
-          <a:bodyPr wrap="square" rtlCol="0" anchor="ctr"/>
-          <a:lstStyle/>
-          <a:p>
-            <a:pPr indent="0" marL="0">
-              <a:buNone/>
-            </a:pPr>
-            <a:r>
-              <a:rPr lang="en-US" sz="900" b="1" i="1" dirty="0">
-                <a:solidFill>
-                  <a:srgbClr val="0079F2"/>
-                </a:solidFill>
-                <a:latin typeface="Arial" pitchFamily="34" charset="0"/>
-                <a:ea typeface="Arial" pitchFamily="34" charset="-122"/>
-                <a:cs typeface="Arial" pitchFamily="34" charset="-120"/>
-              </a:rPr>
-              <a:t>Health → Workforce → Community</a:t>
-            </a:r>
-            <a:endParaRPr lang="en-US" sz="900" dirty="0"/>
-          </a:p>
-        </p:txBody>
-      </p:sp>
-      <p:sp>
-        <p:nvSpPr>
-          <p:cNvPr id="18" name="Shape 16"/>
-          <p:cNvSpPr/>
-          <p:nvPr/>
-        </p:nvSpPr>
-        <p:spPr>
-          <a:xfrm>
-            <a:off x="8229600" y="3246120"/>
-            <a:ext cx="3337560" cy="18288"/>
+              <a:t>Workforce + Business</a:t>
+            </a:r>
+            <a:endParaRPr lang="en-US" sz="950" dirty="0"/>
+          </a:p>
+        </p:txBody>
+      </p:sp>
+      <p:sp>
+        <p:nvSpPr>
+          <p:cNvPr id="28" name="Text 26"/>
+          <p:cNvSpPr/>
+          <p:nvPr/>
+        </p:nvSpPr>
+        <p:spPr>
+          <a:xfrm>
+            <a:off x="6446520" y="4910328"/>
+            <a:ext cx="1325880" cy="256032"/>
+          </a:xfrm>
+          <a:prstGeom prst="rect">
+            <a:avLst/>
+          </a:prstGeom>
+          <a:noFill/>
+          <a:ln/>
+        </p:spPr>
+        <p:txBody>
+          <a:bodyPr wrap="square" rtlCol="0" anchor="ctr"/>
+          <a:lstStyle/>
+          <a:p>
+            <a:pPr algn="r" indent="0" marL="0">
+              <a:buNone/>
+            </a:pPr>
+            <a:r>
+              <a:rPr lang="en-US" sz="950" b="1" dirty="0">
+                <a:solidFill>
+                  <a:srgbClr val="FFFFFF"/>
+                </a:solidFill>
+                <a:latin typeface="Arial" pitchFamily="34" charset="0"/>
+                <a:ea typeface="Arial" pitchFamily="34" charset="-122"/>
+                <a:cs typeface="Arial" pitchFamily="34" charset="-120"/>
+              </a:rPr>
+              <a:t>Income Collapsing</a:t>
+            </a:r>
+            <a:endParaRPr lang="en-US" sz="950" dirty="0"/>
+          </a:p>
+        </p:txBody>
+      </p:sp>
+      <p:sp>
+        <p:nvSpPr>
+          <p:cNvPr id="29" name="Shape 27"/>
+          <p:cNvSpPr/>
+          <p:nvPr/>
+        </p:nvSpPr>
+        <p:spPr>
+          <a:xfrm>
+            <a:off x="4297680" y="5193792"/>
+            <a:ext cx="3429000" cy="18288"/>
           </a:xfrm>
           <a:prstGeom prst="rect">
             <a:avLst/>
@@ -8003,14 +8377,14 @@
       </p:sp>
       <p:sp>
         <p:nvSpPr>
-          <p:cNvPr id="19" name="Text 17"/>
-          <p:cNvSpPr/>
-          <p:nvPr/>
-        </p:nvSpPr>
-        <p:spPr>
-          <a:xfrm>
-            <a:off x="8138160" y="3337560"/>
-            <a:ext cx="3520440" cy="1097280"/>
+          <p:cNvPr id="30" name="Text 28"/>
+          <p:cNvSpPr/>
+          <p:nvPr/>
+        </p:nvSpPr>
+        <p:spPr>
+          <a:xfrm>
+            <a:off x="4251960" y="5257800"/>
+            <a:ext cx="3520440" cy="1371600"/>
           </a:xfrm>
           <a:prstGeom prst="rect">
             <a:avLst/>
@@ -8024,12 +8398,12 @@
           <a:p>
             <a:pPr indent="0" marL="0">
               <a:lnSpc>
-                <a:spcPct val="130000"/>
+                <a:spcPct val="125000"/>
               </a:lnSpc>
               <a:buNone/>
             </a:pPr>
             <a:r>
-              <a:rPr lang="en-US" sz="1000" dirty="0">
+              <a:rPr lang="en-US" sz="950" dirty="0">
                 <a:solidFill>
                   <a:srgbClr val="8B949E"/>
                 </a:solidFill>
@@ -8037,355 +8411,21 @@
                 <a:ea typeface="Arial" pitchFamily="34" charset="-122"/>
                 <a:cs typeface="Arial" pitchFamily="34" charset="-120"/>
               </a:rPr>
-              <a:t>Workforce platform adjusts her job search to part-time/remote. Benefits enrollment through Collaborative Advocate activates disability and FMLA support.</a:t>
-            </a:r>
-            <a:endParaRPr lang="en-US" sz="1000" dirty="0"/>
-          </a:p>
-        </p:txBody>
-      </p:sp>
-      <p:sp>
-        <p:nvSpPr>
-          <p:cNvPr id="20" name="Shape 18"/>
-          <p:cNvSpPr/>
-          <p:nvPr/>
-        </p:nvSpPr>
-        <p:spPr>
-          <a:xfrm>
-            <a:off x="274320" y="4754880"/>
-            <a:ext cx="3703320" cy="1874520"/>
-          </a:xfrm>
-          <a:prstGeom prst="roundRect">
-            <a:avLst>
-              <a:gd name="adj" fmla="val 3902"/>
-            </a:avLst>
-          </a:prstGeom>
-          <a:solidFill>
-            <a:srgbClr val="161B22"/>
-          </a:solidFill>
-          <a:ln w="19050">
-            <a:solidFill>
-              <a:srgbClr val="F0B429"/>
-            </a:solidFill>
-            <a:prstDash val="solid"/>
-          </a:ln>
-        </p:spPr>
-      </p:sp>
-      <p:sp>
-        <p:nvSpPr>
-          <p:cNvPr id="21" name="Text 19"/>
-          <p:cNvSpPr/>
-          <p:nvPr/>
-        </p:nvSpPr>
-        <p:spPr>
-          <a:xfrm>
-            <a:off x="365760" y="4782312"/>
-            <a:ext cx="3520440" cy="320040"/>
-          </a:xfrm>
-          <a:prstGeom prst="rect">
-            <a:avLst/>
-          </a:prstGeom>
-          <a:noFill/>
-          <a:ln/>
-        </p:spPr>
-        <p:txBody>
-          <a:bodyPr wrap="square" rtlCol="0" anchor="ctr"/>
-          <a:lstStyle/>
-          <a:p>
-            <a:pPr indent="0" marL="0">
-              <a:buNone/>
-            </a:pPr>
-            <a:r>
-              <a:rPr lang="en-US" sz="1200" b="1" dirty="0">
-                <a:solidFill>
-                  <a:srgbClr val="F0B429"/>
-                </a:solidFill>
-                <a:latin typeface="Arial" pitchFamily="34" charset="0"/>
-                <a:ea typeface="Arial" pitchFamily="34" charset="-122"/>
-                <a:cs typeface="Arial" pitchFamily="34" charset="-120"/>
-              </a:rPr>
-              <a:t>Nonprofit struggling</a:t>
-            </a:r>
-            <a:endParaRPr lang="en-US" sz="1200" dirty="0"/>
-          </a:p>
-        </p:txBody>
-      </p:sp>
-      <p:sp>
-        <p:nvSpPr>
-          <p:cNvPr id="22" name="Text 20"/>
-          <p:cNvSpPr/>
-          <p:nvPr/>
-        </p:nvSpPr>
-        <p:spPr>
-          <a:xfrm>
-            <a:off x="365760" y="5074920"/>
-            <a:ext cx="3520440" cy="228600"/>
-          </a:xfrm>
-          <a:prstGeom prst="rect">
-            <a:avLst/>
-          </a:prstGeom>
-          <a:noFill/>
-          <a:ln/>
-        </p:spPr>
-        <p:txBody>
-          <a:bodyPr wrap="square" rtlCol="0" anchor="ctr"/>
-          <a:lstStyle/>
-          <a:p>
-            <a:pPr indent="0" marL="0">
-              <a:buNone/>
-            </a:pPr>
-            <a:r>
-              <a:rPr lang="en-US" sz="900" b="1" i="1" dirty="0">
-                <a:solidFill>
-                  <a:srgbClr val="F0B429"/>
-                </a:solidFill>
-                <a:latin typeface="Arial" pitchFamily="34" charset="0"/>
-                <a:ea typeface="Arial" pitchFamily="34" charset="-122"/>
-                <a:cs typeface="Arial" pitchFamily="34" charset="-120"/>
-              </a:rPr>
-              <a:t>Business → Community</a:t>
-            </a:r>
-            <a:endParaRPr lang="en-US" sz="900" dirty="0"/>
-          </a:p>
-        </p:txBody>
-      </p:sp>
-      <p:sp>
-        <p:nvSpPr>
-          <p:cNvPr id="23" name="Shape 21"/>
-          <p:cNvSpPr/>
-          <p:nvPr/>
-        </p:nvSpPr>
-        <p:spPr>
-          <a:xfrm>
-            <a:off x="457200" y="5303520"/>
-            <a:ext cx="3337560" cy="18288"/>
-          </a:xfrm>
-          <a:prstGeom prst="rect">
-            <a:avLst/>
-          </a:prstGeom>
-          <a:solidFill>
-            <a:srgbClr val="F0B429"/>
-          </a:solidFill>
-          <a:ln/>
-        </p:spPr>
-      </p:sp>
-      <p:sp>
-        <p:nvSpPr>
-          <p:cNvPr id="24" name="Text 22"/>
-          <p:cNvSpPr/>
-          <p:nvPr/>
-        </p:nvSpPr>
-        <p:spPr>
-          <a:xfrm>
-            <a:off x="365760" y="5394960"/>
-            <a:ext cx="3520440" cy="1097280"/>
-          </a:xfrm>
-          <a:prstGeom prst="rect">
-            <a:avLst/>
-          </a:prstGeom>
-          <a:noFill/>
-          <a:ln/>
-        </p:spPr>
-        <p:txBody>
-          <a:bodyPr wrap="square" rtlCol="0" anchor="ctr"/>
-          <a:lstStyle/>
-          <a:p>
-            <a:pPr indent="0" marL="0">
-              <a:lnSpc>
-                <a:spcPct val="130000"/>
-              </a:lnSpc>
-              <a:buNone/>
-            </a:pPr>
-            <a:r>
-              <a:rPr lang="en-US" sz="1000" dirty="0">
-                <a:solidFill>
-                  <a:srgbClr val="8B949E"/>
-                </a:solidFill>
-                <a:latin typeface="Arial" pitchFamily="34" charset="0"/>
-                <a:ea typeface="Arial" pitchFamily="34" charset="-122"/>
-                <a:cs typeface="Arial" pitchFamily="34" charset="-120"/>
-              </a:rPr>
-              <a:t>Minority Center of Excellence connects her to emergency small business resources. Pinnacle flags mentorship opportunities. Her grants pipeline stays warm.</a:t>
-            </a:r>
-            <a:endParaRPr lang="en-US" sz="1000" dirty="0"/>
-          </a:p>
-        </p:txBody>
-      </p:sp>
-      <p:sp>
-        <p:nvSpPr>
-          <p:cNvPr id="25" name="Shape 23"/>
-          <p:cNvSpPr/>
-          <p:nvPr/>
-        </p:nvSpPr>
-        <p:spPr>
-          <a:xfrm>
-            <a:off x="4160520" y="4754880"/>
-            <a:ext cx="3703320" cy="1874520"/>
-          </a:xfrm>
-          <a:prstGeom prst="roundRect">
-            <a:avLst>
-              <a:gd name="adj" fmla="val 3902"/>
-            </a:avLst>
-          </a:prstGeom>
-          <a:solidFill>
-            <a:srgbClr val="161B22"/>
-          </a:solidFill>
-          <a:ln w="19050">
-            <a:solidFill>
-              <a:srgbClr val="F97316"/>
-            </a:solidFill>
-            <a:prstDash val="solid"/>
-          </a:ln>
-        </p:spPr>
-      </p:sp>
-      <p:sp>
-        <p:nvSpPr>
-          <p:cNvPr id="26" name="Text 24"/>
-          <p:cNvSpPr/>
-          <p:nvPr/>
-        </p:nvSpPr>
-        <p:spPr>
-          <a:xfrm>
-            <a:off x="4251960" y="4782312"/>
-            <a:ext cx="3520440" cy="320040"/>
-          </a:xfrm>
-          <a:prstGeom prst="rect">
-            <a:avLst/>
-          </a:prstGeom>
-          <a:noFill/>
-          <a:ln/>
-        </p:spPr>
-        <p:txBody>
-          <a:bodyPr wrap="square" rtlCol="0" anchor="ctr"/>
-          <a:lstStyle/>
-          <a:p>
-            <a:pPr indent="0" marL="0">
-              <a:buNone/>
-            </a:pPr>
-            <a:r>
-              <a:rPr lang="en-US" sz="1200" b="1" dirty="0">
-                <a:solidFill>
-                  <a:srgbClr val="F97316"/>
-                </a:solidFill>
-                <a:latin typeface="Arial" pitchFamily="34" charset="0"/>
-                <a:ea typeface="Arial" pitchFamily="34" charset="-122"/>
-                <a:cs typeface="Arial" pitchFamily="34" charset="-120"/>
-              </a:rPr>
-              <a:t>Daughter's grades drop</a:t>
-            </a:r>
-            <a:endParaRPr lang="en-US" sz="1200" dirty="0"/>
-          </a:p>
-        </p:txBody>
-      </p:sp>
-      <p:sp>
-        <p:nvSpPr>
-          <p:cNvPr id="27" name="Text 25"/>
-          <p:cNvSpPr/>
-          <p:nvPr/>
-        </p:nvSpPr>
-        <p:spPr>
-          <a:xfrm>
-            <a:off x="4251960" y="5074920"/>
-            <a:ext cx="3520440" cy="228600"/>
-          </a:xfrm>
-          <a:prstGeom prst="rect">
-            <a:avLst/>
-          </a:prstGeom>
-          <a:noFill/>
-          <a:ln/>
-        </p:spPr>
-        <p:txBody>
-          <a:bodyPr wrap="square" rtlCol="0" anchor="ctr"/>
-          <a:lstStyle/>
-          <a:p>
-            <a:pPr indent="0" marL="0">
-              <a:buNone/>
-            </a:pPr>
-            <a:r>
-              <a:rPr lang="en-US" sz="900" b="1" i="1" dirty="0">
-                <a:solidFill>
-                  <a:srgbClr val="F97316"/>
-                </a:solidFill>
-                <a:latin typeface="Arial" pitchFamily="34" charset="0"/>
-                <a:ea typeface="Arial" pitchFamily="34" charset="-122"/>
-                <a:cs typeface="Arial" pitchFamily="34" charset="-120"/>
-              </a:rPr>
-              <a:t>Education → Family → Health</a:t>
-            </a:r>
-            <a:endParaRPr lang="en-US" sz="900" dirty="0"/>
-          </a:p>
-        </p:txBody>
-      </p:sp>
-      <p:sp>
-        <p:nvSpPr>
-          <p:cNvPr id="28" name="Shape 26"/>
-          <p:cNvSpPr/>
-          <p:nvPr/>
-        </p:nvSpPr>
-        <p:spPr>
-          <a:xfrm>
-            <a:off x="4343400" y="5303520"/>
-            <a:ext cx="3337560" cy="18288"/>
-          </a:xfrm>
-          <a:prstGeom prst="rect">
-            <a:avLst/>
-          </a:prstGeom>
-          <a:solidFill>
-            <a:srgbClr val="F97316"/>
-          </a:solidFill>
-          <a:ln/>
-        </p:spPr>
-      </p:sp>
-      <p:sp>
-        <p:nvSpPr>
-          <p:cNvPr id="29" name="Text 27"/>
-          <p:cNvSpPr/>
-          <p:nvPr/>
-        </p:nvSpPr>
-        <p:spPr>
-          <a:xfrm>
-            <a:off x="4251960" y="5394960"/>
-            <a:ext cx="3520440" cy="1097280"/>
-          </a:xfrm>
-          <a:prstGeom prst="rect">
-            <a:avLst/>
-          </a:prstGeom>
-          <a:noFill/>
-          <a:ln/>
-        </p:spPr>
-        <p:txBody>
-          <a:bodyPr wrap="square" rtlCol="0" anchor="ctr"/>
-          <a:lstStyle/>
-          <a:p>
-            <a:pPr indent="0" marL="0">
-              <a:lnSpc>
-                <a:spcPct val="130000"/>
-              </a:lnSpc>
-              <a:buNone/>
-            </a:pPr>
-            <a:r>
-              <a:rPr lang="en-US" sz="1000" dirty="0">
-                <a:solidFill>
-                  <a:srgbClr val="8B949E"/>
-                </a:solidFill>
-                <a:latin typeface="Arial" pitchFamily="34" charset="0"/>
-                <a:ea typeface="Arial" pitchFamily="34" charset="-122"/>
-                <a:cs typeface="Arial" pitchFamily="34" charset="-120"/>
-              </a:rPr>
-              <a:t>ThriveUp Academy alerts school liaison. The system checks: is this connected to mom's health crisis? Yes — family services activates. Perfectly Different checks if she needs additional support.</a:t>
-            </a:r>
-            <a:endParaRPr lang="en-US" sz="1000" dirty="0"/>
-          </a:p>
-        </p:txBody>
-      </p:sp>
-      <p:sp>
-        <p:nvSpPr>
-          <p:cNvPr id="30" name="Shape 28"/>
-          <p:cNvSpPr/>
-          <p:nvPr/>
-        </p:nvSpPr>
-        <p:spPr>
-          <a:xfrm>
-            <a:off x="8046720" y="4754880"/>
+              <a:t>Keisha can't work full-time through cancer AND pregnancy. Workforce shifts her profile to part-time/remote. Minority Center of Excellence provides emergency nonprofit continuity. Collaborative Advocate activates FMLA, disability, WIC, childcare assistance — all in one record.</a:t>
+            </a:r>
+            <a:endParaRPr lang="en-US" sz="950" dirty="0"/>
+          </a:p>
+        </p:txBody>
+      </p:sp>
+      <p:sp>
+        <p:nvSpPr>
+          <p:cNvPr id="31" name="Shape 29"/>
+          <p:cNvSpPr/>
+          <p:nvPr/>
+        </p:nvSpPr>
+        <p:spPr>
+          <a:xfrm>
+            <a:off x="8046720" y="4892040"/>
             <a:ext cx="3703320" cy="1874520"/>
           </a:xfrm>
           <a:prstGeom prst="roundRect">
@@ -8406,30 +8446,30 @@
       </p:sp>
       <p:sp>
         <p:nvSpPr>
-          <p:cNvPr id="31" name="Text 29"/>
-          <p:cNvSpPr/>
-          <p:nvPr/>
-        </p:nvSpPr>
-        <p:spPr>
-          <a:xfrm>
-            <a:off x="8138160" y="4782312"/>
-            <a:ext cx="3520440" cy="320040"/>
-          </a:xfrm>
-          <a:prstGeom prst="rect">
-            <a:avLst/>
-          </a:prstGeom>
-          <a:noFill/>
-          <a:ln/>
-        </p:spPr>
-        <p:txBody>
-          <a:bodyPr wrap="square" rtlCol="0" anchor="ctr"/>
-          <a:lstStyle/>
-          <a:p>
-            <a:pPr indent="0" marL="0">
-              <a:buNone/>
-            </a:pPr>
-            <a:r>
-              <a:rPr lang="en-US" sz="1200" b="1" dirty="0">
+          <p:cNvPr id="32" name="Text 30"/>
+          <p:cNvSpPr/>
+          <p:nvPr/>
+        </p:nvSpPr>
+        <p:spPr>
+          <a:xfrm>
+            <a:off x="8138160" y="4910328"/>
+            <a:ext cx="2286000" cy="256032"/>
+          </a:xfrm>
+          <a:prstGeom prst="rect">
+            <a:avLst/>
+          </a:prstGeom>
+          <a:noFill/>
+          <a:ln/>
+        </p:spPr>
+        <p:txBody>
+          <a:bodyPr wrap="square" rtlCol="0" anchor="ctr"/>
+          <a:lstStyle/>
+          <a:p>
+            <a:pPr indent="0" marL="0">
+              <a:buNone/>
+            </a:pPr>
+            <a:r>
+              <a:rPr lang="en-US" sz="950" b="1" dirty="0">
                 <a:solidFill>
                   <a:srgbClr val="00C9A7"/>
                 </a:solidFill>
@@ -8437,61 +8477,61 @@
                 <a:ea typeface="Arial" pitchFamily="34" charset="-122"/>
                 <a:cs typeface="Arial" pitchFamily="34" charset="-120"/>
               </a:rPr>
-              <a:t>AI sees the whole picture</a:t>
-            </a:r>
-            <a:endParaRPr lang="en-US" sz="1200" dirty="0"/>
-          </a:p>
-        </p:txBody>
-      </p:sp>
-      <p:sp>
-        <p:nvSpPr>
-          <p:cNvPr id="32" name="Text 30"/>
-          <p:cNvSpPr/>
-          <p:nvPr/>
-        </p:nvSpPr>
-        <p:spPr>
-          <a:xfrm>
-            <a:off x="8138160" y="5074920"/>
-            <a:ext cx="3520440" cy="228600"/>
-          </a:xfrm>
-          <a:prstGeom prst="rect">
-            <a:avLst/>
-          </a:prstGeom>
-          <a:noFill/>
-          <a:ln/>
-        </p:spPr>
-        <p:txBody>
-          <a:bodyPr wrap="square" rtlCol="0" anchor="ctr"/>
-          <a:lstStyle/>
-          <a:p>
-            <a:pPr indent="0" marL="0">
-              <a:buNone/>
-            </a:pPr>
-            <a:r>
-              <a:rPr lang="en-US" sz="900" b="1" i="1" dirty="0">
-                <a:solidFill>
-                  <a:srgbClr val="00C9A7"/>
-                </a:solidFill>
-                <a:latin typeface="Arial" pitchFamily="34" charset="0"/>
-                <a:ea typeface="Arial" pitchFamily="34" charset="-122"/>
-                <a:cs typeface="Arial" pitchFamily="34" charset="-120"/>
-              </a:rPr>
-              <a:t>AI → Everything</a:t>
-            </a:r>
-            <a:endParaRPr lang="en-US" sz="900" dirty="0"/>
-          </a:p>
-        </p:txBody>
-      </p:sp>
-      <p:sp>
-        <p:nvSpPr>
-          <p:cNvPr id="33" name="Shape 31"/>
-          <p:cNvSpPr/>
-          <p:nvPr/>
-        </p:nvSpPr>
-        <p:spPr>
-          <a:xfrm>
-            <a:off x="8229600" y="5303520"/>
-            <a:ext cx="3337560" cy="18288"/>
+              <a:t>AI Intelligence Layer</a:t>
+            </a:r>
+            <a:endParaRPr lang="en-US" sz="950" dirty="0"/>
+          </a:p>
+        </p:txBody>
+      </p:sp>
+      <p:sp>
+        <p:nvSpPr>
+          <p:cNvPr id="33" name="Text 31"/>
+          <p:cNvSpPr/>
+          <p:nvPr/>
+        </p:nvSpPr>
+        <p:spPr>
+          <a:xfrm>
+            <a:off x="10332720" y="4910328"/>
+            <a:ext cx="1325880" cy="256032"/>
+          </a:xfrm>
+          <a:prstGeom prst="rect">
+            <a:avLst/>
+          </a:prstGeom>
+          <a:noFill/>
+          <a:ln/>
+        </p:spPr>
+        <p:txBody>
+          <a:bodyPr wrap="square" rtlCol="0" anchor="ctr"/>
+          <a:lstStyle/>
+          <a:p>
+            <a:pPr algn="r" indent="0" marL="0">
+              <a:buNone/>
+            </a:pPr>
+            <a:r>
+              <a:rPr lang="en-US" sz="950" b="1" dirty="0">
+                <a:solidFill>
+                  <a:srgbClr val="FFFFFF"/>
+                </a:solidFill>
+                <a:latin typeface="Arial" pitchFamily="34" charset="0"/>
+                <a:ea typeface="Arial" pitchFamily="34" charset="-122"/>
+                <a:cs typeface="Arial" pitchFamily="34" charset="-120"/>
+              </a:rPr>
+              <a:t>No Human Can Do This</a:t>
+            </a:r>
+            <a:endParaRPr lang="en-US" sz="950" dirty="0"/>
+          </a:p>
+        </p:txBody>
+      </p:sp>
+      <p:sp>
+        <p:nvSpPr>
+          <p:cNvPr id="34" name="Shape 32"/>
+          <p:cNvSpPr/>
+          <p:nvPr/>
+        </p:nvSpPr>
+        <p:spPr>
+          <a:xfrm>
+            <a:off x="8183880" y="5193792"/>
+            <a:ext cx="3429000" cy="18288"/>
           </a:xfrm>
           <a:prstGeom prst="rect">
             <a:avLst/>
@@ -8504,14 +8544,14 @@
       </p:sp>
       <p:sp>
         <p:nvSpPr>
-          <p:cNvPr id="34" name="Text 32"/>
-          <p:cNvSpPr/>
-          <p:nvPr/>
-        </p:nvSpPr>
-        <p:spPr>
-          <a:xfrm>
-            <a:off x="8138160" y="5394960"/>
-            <a:ext cx="3520440" cy="1097280"/>
+          <p:cNvPr id="35" name="Text 33"/>
+          <p:cNvSpPr/>
+          <p:nvPr/>
+        </p:nvSpPr>
+        <p:spPr>
+          <a:xfrm>
+            <a:off x="8138160" y="5257800"/>
+            <a:ext cx="3520440" cy="1371600"/>
           </a:xfrm>
           <a:prstGeom prst="rect">
             <a:avLst/>
@@ -8525,12 +8565,12 @@
           <a:p>
             <a:pPr indent="0" marL="0">
               <a:lnSpc>
-                <a:spcPct val="130000"/>
+                <a:spcPct val="125000"/>
               </a:lnSpc>
               <a:buNone/>
             </a:pPr>
             <a:r>
-              <a:rPr lang="en-US" sz="1000" dirty="0">
+              <a:rPr lang="en-US" sz="950" dirty="0">
                 <a:solidFill>
                   <a:srgbClr val="8B949E"/>
                 </a:solidFill>
@@ -8538,9 +8578,9 @@
                 <a:ea typeface="Arial" pitchFamily="34" charset="-122"/>
                 <a:cs typeface="Arial" pitchFamily="34" charset="-120"/>
               </a:rPr>
-              <a:t>No human case manager could connect all these dots across 6 domains. The AI intelligence layer sees: cancer + depression + job loss + business struggle + child's grades. One person. One record. Every platform responding.</a:t>
-            </a:r>
-            <a:endParaRPr lang="en-US" sz="1000" dirty="0"/>
+              <a:t>Cancer protocol + pregnancy risk + depression + child's grades + job loss + medication interactions + housing stability. The AI sees ALL of it across ALL domains simultaneously. It alerts the right providers before crisis — because no case manager can track this many signals across this many systems.</a:t>
+            </a:r>
+            <a:endParaRPr lang="en-US" sz="950" dirty="0"/>
           </a:p>
         </p:txBody>
       </p:sp>
@@ -8671,7 +8711,7 @@
                 <a:ea typeface="Arial" pitchFamily="34" charset="-122"/>
                 <a:cs typeface="Arial" pitchFamily="34" charset="-120"/>
               </a:rPr>
-              <a:t>Keisha's Brother Marcus</a:t>
+              <a:t>Then Her Brother Marcus</a:t>
             </a:r>
             <a:endParaRPr lang="en-US" sz="3300" dirty="0"/>
           </a:p>
@@ -8733,7 +8773,7 @@
                 <a:ea typeface="Arial" pitchFamily="34" charset="-122"/>
                 <a:cs typeface="Arial" pitchFamily="34" charset="-120"/>
               </a:rPr>
-              <a:t>Same family. Same ecosystem. Marcus is released after 4 years. Today, he'd get a bus ticket. In ThriveUp, every platform his sister already uses knows he's coming — and they're ready:</a:t>
+              <a:t>Same family. Same ecosystem. Marcus is released after 4 years. He also served. In the current system, he'd get a bus ticket. In ThriveUp, his sister's family file means every platform already knows he's coming — and his niece already has supports in place:</a:t>
             </a:r>
             <a:endParaRPr lang="en-US" sz="1300" dirty="0"/>
           </a:p>
@@ -8900,7 +8940,7 @@
                 <a:ea typeface="Arial" pitchFamily="34" charset="-122"/>
                 <a:cs typeface="Arial" pitchFamily="34" charset="-120"/>
               </a:rPr>
-              <a:t>Reentry profile. One record connected to every platform. Keisha's family file already exists — Marcus joins it. Housing, health, employment assessed.</a:t>
+              <a:t>Reentry profile. Keisha's family file already exists — Marcus joins it. His niece's school supports, his sister's medical team, the community resources they use — all visible. One intake, not eight.</a:t>
             </a:r>
             <a:endParaRPr lang="en-US" sz="1000" dirty="0"/>
           </a:p>
@@ -9005,7 +9045,7 @@
                 <a:ea typeface="Arial" pitchFamily="34" charset="-122"/>
                 <a:cs typeface="Arial" pitchFamily="34" charset="-120"/>
               </a:rPr>
-              <a:t>Workforce + Veteran</a:t>
+              <a:t>Mission Transition</a:t>
             </a:r>
             <a:endParaRPr lang="en-US" sz="1100" dirty="0"/>
           </a:p>
@@ -9067,7 +9107,7 @@
                 <a:ea typeface="Arial" pitchFamily="34" charset="-122"/>
                 <a:cs typeface="Arial" pitchFamily="34" charset="-120"/>
               </a:rPr>
-              <a:t>Marcus served too. Mission Transition maps his military + prison work experience to civilian jobs. AI matches him to 3 employers.</a:t>
+              <a:t>Marcus served too. Military + prison work experience mapped to civilian jobs. AI matches 3 employers. If he needs training, ThriveUp Academy activates. Connected to his niece's education record.</a:t>
             </a:r>
             <a:endParaRPr lang="en-US" sz="1000" dirty="0"/>
           </a:p>
@@ -9234,7 +9274,7 @@
                 <a:ea typeface="Arial" pitchFamily="34" charset="-122"/>
                 <a:cs typeface="Arial" pitchFamily="34" charset="-120"/>
               </a:rPr>
-              <a:t>Behavioral health screen. Substance abuse flagged. Matched to a provider who understands reentry AND veteran experience.</a:t>
+              <a:t>Behavioral health screening. Substance abuse flagged. Matched to a provider who understands BOTH reentry AND veteran experience. PillScheduler if medication needed.</a:t>
             </a:r>
             <a:endParaRPr lang="en-US" sz="1000" dirty="0"/>
           </a:p>
@@ -9339,7 +9379,7 @@
                 <a:ea typeface="Arial" pitchFamily="34" charset="-122"/>
                 <a:cs typeface="Arial" pitchFamily="34" charset="-120"/>
               </a:rPr>
-              <a:t>SafeReport + ISSS</a:t>
+              <a:t>ISSS + SafeReport</a:t>
             </a:r>
             <a:endParaRPr lang="en-US" sz="1100" dirty="0"/>
           </a:p>
@@ -9401,7 +9441,7 @@
                 <a:ea typeface="Arial" pitchFamily="34" charset="-122"/>
                 <a:cs typeface="Arial" pitchFamily="34" charset="-120"/>
               </a:rPr>
-              <a:t>Family reunification. His kids get youth support through ISSS. Mandated reporting compliance built in. The ecosystem protects everyone.</a:t>
+              <a:t>If Marcus has kids — family reunification. Mandated reporting compliance built in. Youth supports for ALL children in the family. His niece now has an uncle in the picture — ISSS adjusts her support plan.</a:t>
             </a:r>
             <a:endParaRPr lang="en-US" sz="1000" dirty="0"/>
           </a:p>
@@ -9568,7 +9608,7 @@
                 <a:ea typeface="Arial" pitchFamily="34" charset="-122"/>
                 <a:cs typeface="Arial" pitchFamily="34" charset="-120"/>
               </a:rPr>
-              <a:t>Legal aid. Record expungement. Benefits. All in the same system Keisha uses — the family is connected, not siloed.</a:t>
+              <a:t>Legal aid. Record expungement. Benefits. All in the same system Keisha uses. The family is connected — not siloed across agencies that will never coordinate.</a:t>
             </a:r>
             <a:endParaRPr lang="en-US" sz="1000" dirty="0"/>
           </a:p>
@@ -9735,7 +9775,7 @@
                 <a:ea typeface="Arial" pitchFamily="34" charset="-122"/>
                 <a:cs typeface="Arial" pitchFamily="34" charset="-120"/>
               </a:rPr>
-              <a:t>If anything destabilizes — job, health, housing — the whole team is alerted before crisis. The ecosystem doesn't wait for failure.</a:t>
+              <a:t>If anything destabilizes — job, health, housing — the whole team alerts before crisis. The ecosystem already learned from Keisha's journey. It wraps around Marcus AND the family.</a:t>
             </a:r>
             <a:endParaRPr lang="en-US" sz="1000" dirty="0"/>
           </a:p>
@@ -9868,7 +9908,7 @@
                 <a:ea typeface="Arial" pitchFamily="34" charset="-122"/>
                 <a:cs typeface="Arial" pitchFamily="34" charset="-120"/>
               </a:rPr>
-              <a:t>Because No Human Can Connect All These Dots</a:t>
+              <a:t>Because No Human Can Connect These Dots</a:t>
             </a:r>
             <a:endParaRPr lang="en-US" sz="3300" dirty="0"/>
           </a:p>
@@ -9910,7 +9950,7 @@
                 <a:ea typeface="Arial" pitchFamily="34" charset="-122"/>
                 <a:cs typeface="Arial" pitchFamily="34" charset="-120"/>
               </a:rPr>
-              <a:t>Keisha has needs across 6 domains. Marcus has needs across 5. Their children across 3. No case manager can track all of that. The AI can — because it sees every platform, every record, every signal, in real time.</a:t>
+              <a:t>Keisha has needs across 6 domains. Her unborn child adds another layer. Her daughter is struggling in school. Her brother Marcus just came home. No case manager can track all of that across all those systems. The AI can.</a:t>
             </a:r>
             <a:endParaRPr lang="en-US" sz="1300" dirty="0"/>
           </a:p>
@@ -10035,7 +10075,7 @@
                 <a:ea typeface="Arial" pitchFamily="34" charset="-122"/>
                 <a:cs typeface="Arial" pitchFamily="34" charset="-120"/>
               </a:rPr>
-              <a:t>Keisha's treatment intensifies + depression worsens + work hours drop = high-risk alert to her entire care team, employer, and family services — BEFORE crisis.</a:t>
+              <a:t>Keisha's chemo changes + pregnancy confirmed + depression worsens + daughter's grades drop = multi-provider alert. Oncologist, OB, counselor, school, and ISSS all see it. BEFORE anyone falls through the cracks.</a:t>
             </a:r>
             <a:endParaRPr lang="en-US" sz="1050" dirty="0"/>
           </a:p>
@@ -10160,7 +10200,7 @@
                 <a:ea typeface="Arial" pitchFamily="34" charset="-122"/>
                 <a:cs typeface="Arial" pitchFamily="34" charset="-120"/>
               </a:rPr>
-              <a:t>Marcus's daughter's grades drop → system checks parent file → sees his recent job change + housing move → flags school counselor AND family services. One signal, four platforms respond.</a:t>
+              <a:t>Daughter's grades drop from B's to D's → AI checks family file → sees mom's cancer + pregnancy + depression + work reduction → flags school counselor AND ISSS AND family support. The school finally knows WHY.</a:t>
             </a:r>
             <a:endParaRPr lang="en-US" sz="1050" dirty="0"/>
           </a:p>
@@ -10285,7 +10325,7 @@
                 <a:ea typeface="Arial" pitchFamily="34" charset="-122"/>
                 <a:cs typeface="Arial" pitchFamily="34" charset="-120"/>
               </a:rPr>
-              <a:t>If a referral sits unacknowledged, a screening is overdue, or a service gap is growing — the AI flags it. Platforms hold each other accountable because AI monitors every handoff.</a:t>
+              <a:t>ISSS wrapped tutoring around the daughter 2 weeks ago. Grades haven't improved. AI flags it — is the intervention working? Does she need Perfectly Different screening? Platforms don't just refer. They follow up.</a:t>
             </a:r>
             <a:endParaRPr lang="en-US" sz="1050" dirty="0"/>
           </a:p>
@@ -10410,7 +10450,7 @@
                 <a:ea typeface="Arial" pitchFamily="34" charset="-122"/>
                 <a:cs typeface="Arial" pitchFamily="34" charset="-120"/>
               </a:rPr>
-              <a:t>4 AI models (GPT-4o, Claude, Gemini, DeepSeek) process every critical decision. Risk assessments, care plans, proposals — all consensus-verified. No single point of failure.</a:t>
+              <a:t>4 AI models (GPT-4o, Claude, Gemini, DeepSeek) process critical decisions together — medication safety during pregnancy + chemo, family risk scoring, child support plans. No single model decides alone.</a:t>
             </a:r>
             <a:endParaRPr lang="en-US" sz="1050" dirty="0"/>
           </a:p>
@@ -10585,7 +10625,7 @@
                 <a:ea typeface="Arial" pitchFamily="34" charset="-122"/>
                 <a:cs typeface="Arial" pitchFamily="34" charset="-120"/>
               </a:rPr>
-              <a:t>A school district starts with Education + Behavioral Health. A reentry program starts with LifeBridge + Workforce. A health center starts with Maternal Health + Community Navigation. Then they see what's connected — and they expand. Every expansion is recurring revenue.</a:t>
+              <a:t>A school district starts with Education + ISSS. A reentry program starts with LifeBridge + Workforce. A health center starts with Maternal Health + Cancer Navigation. Then they see what's connected — and they expand. Every expansion is recurring revenue.</a:t>
             </a:r>
             <a:endParaRPr lang="en-US" sz="1300" dirty="0"/>
           </a:p>
@@ -10814,7 +10854,7 @@
                 <a:ea typeface="Arial" pitchFamily="34" charset="-122"/>
                 <a:cs typeface="Arial" pitchFamily="34" charset="-120"/>
               </a:rPr>
-              <a:t>School district: Education + Behavioral Health</a:t>
+              <a:t>School district: Academy + ISSS + BH</a:t>
             </a:r>
             <a:endParaRPr lang="en-US" sz="1000" dirty="0"/>
           </a:p>
@@ -10854,7 +10894,7 @@
                 <a:ea typeface="Arial" pitchFamily="34" charset="-122"/>
                 <a:cs typeface="Arial" pitchFamily="34" charset="-120"/>
               </a:rPr>
-              <a:t>Health center: Maternal + Community Nav</a:t>
+              <a:t>Health center: Maternal + Sankofa</a:t>
             </a:r>
             <a:endParaRPr lang="en-US" sz="1000" dirty="0"/>
           </a:p>
@@ -11083,7 +11123,7 @@
                 <a:ea typeface="Arial" pitchFamily="34" charset="-122"/>
                 <a:cs typeface="Arial" pitchFamily="34" charset="-120"/>
               </a:rPr>
-              <a:t>School adds SafeReport + Family Services</a:t>
+              <a:t>School adds SafeReport + Workforce</a:t>
             </a:r>
             <a:endParaRPr lang="en-US" sz="1000" dirty="0"/>
           </a:p>
@@ -11123,7 +11163,7 @@
                 <a:ea typeface="Arial" pitchFamily="34" charset="-122"/>
                 <a:cs typeface="Arial" pitchFamily="34" charset="-120"/>
               </a:rPr>
-              <a:t>Health center adds Workforce + Mental Health</a:t>
+              <a:t>Health adds Workforce + BH + Community</a:t>
             </a:r>
             <a:endParaRPr lang="en-US" sz="1000" dirty="0"/>
           </a:p>
@@ -11352,7 +11392,7 @@
                 <a:ea typeface="Arial" pitchFamily="34" charset="-122"/>
                 <a:cs typeface="Arial" pitchFamily="34" charset="-120"/>
               </a:rPr>
-              <a:t>Community action agency deploys everything.</a:t>
+              <a:t>Community agency deploys everything.</a:t>
             </a:r>
             <a:endParaRPr lang="en-US" sz="1000" dirty="0"/>
           </a:p>
@@ -11372,7 +11412,7 @@
                 <a:ea typeface="Arial" pitchFamily="34" charset="-122"/>
                 <a:cs typeface="Arial" pitchFamily="34" charset="-120"/>
               </a:rPr>
-              <a:t>One architecture. One record. Whole person.</a:t>
+              <a:t>One family like Keisha's — one record.</a:t>
             </a:r>
             <a:endParaRPr lang="en-US" sz="1000" dirty="0"/>
           </a:p>
@@ -11392,7 +11432,7 @@
                 <a:ea typeface="Arial" pitchFamily="34" charset="-122"/>
                 <a:cs typeface="Arial" pitchFamily="34" charset="-120"/>
               </a:rPr>
-              <a:t>Maximum impact. Maximum recurring revenue.</a:t>
+              <a:t>Maximum impact. Maximum revenue.</a:t>
             </a:r>
             <a:endParaRPr lang="en-US" sz="1000" dirty="0"/>
           </a:p>

</xml_diff>